<commit_message>
added data from France & updated powerpoint
</commit_message>
<xml_diff>
--- a/Data-Science-Project2Präsi.pptx
+++ b/Data-Science-Project2Präsi.pptx
@@ -5,10 +5,10 @@
     <p:sldMasterId id="2147483666" r:id="rId4"/>
   </p:sldMasterIdLst>
   <p:notesMasterIdLst>
-    <p:notesMasterId r:id="rId15"/>
+    <p:notesMasterId r:id="rId19"/>
   </p:notesMasterIdLst>
   <p:handoutMasterIdLst>
-    <p:handoutMasterId r:id="rId16"/>
+    <p:handoutMasterId r:id="rId20"/>
   </p:handoutMasterIdLst>
   <p:sldIdLst>
     <p:sldId id="314" r:id="rId5"/>
@@ -17,10 +17,14 @@
     <p:sldId id="318" r:id="rId8"/>
     <p:sldId id="327" r:id="rId9"/>
     <p:sldId id="329" r:id="rId10"/>
-    <p:sldId id="328" r:id="rId11"/>
-    <p:sldId id="331" r:id="rId12"/>
-    <p:sldId id="330" r:id="rId13"/>
-    <p:sldId id="309" r:id="rId14"/>
+    <p:sldId id="332" r:id="rId11"/>
+    <p:sldId id="333" r:id="rId12"/>
+    <p:sldId id="328" r:id="rId13"/>
+    <p:sldId id="334" r:id="rId14"/>
+    <p:sldId id="335" r:id="rId15"/>
+    <p:sldId id="336" r:id="rId16"/>
+    <p:sldId id="330" r:id="rId17"/>
+    <p:sldId id="309" r:id="rId18"/>
   </p:sldIdLst>
   <p:sldSz cx="12192000" cy="6858000"/>
   <p:notesSz cx="6858000" cy="9144000"/>
@@ -153,6 +157,14 @@
 </p:cmAuthorLst>
 </file>
 
+<file path=ppt/revisionInfo.xml><?xml version="1.0" encoding="utf-8"?>
+<p1510:revInfo xmlns:a="http://schemas.openxmlformats.org/drawingml/2006/main" xmlns:r="http://schemas.openxmlformats.org/officeDocument/2006/relationships" xmlns:p1510="http://schemas.microsoft.com/office/powerpoint/2015/10/main">
+  <p1510:revLst>
+    <p1510:client id="{6BE95485-D216-79C7-4188-09F4ADE0DC05}" v="229" dt="2026-03-04T21:45:04.332"/>
+  </p1510:revLst>
+</p1510:revInfo>
+</file>
+
 <file path=ppt/handoutMasters/handoutMaster1.xml><?xml version="1.0" encoding="utf-8"?>
 <p:handoutMaster xmlns:a="http://schemas.openxmlformats.org/drawingml/2006/main" xmlns:r="http://schemas.openxmlformats.org/officeDocument/2006/relationships" xmlns:p="http://schemas.openxmlformats.org/presentationml/2006/main">
   <p:cSld>
@@ -780,6 +792,438 @@
   <p:cSld>
     <p:spTree>
       <p:nvGrpSpPr>
+        <p:cNvPr id="1" name="">
+          <a:extLst>
+            <a:ext uri="{FF2B5EF4-FFF2-40B4-BE49-F238E27FC236}">
+              <a16:creationId xmlns:a16="http://schemas.microsoft.com/office/drawing/2014/main" id="{D0FAE2C1-43D5-CF9C-FE5B-8A587B2C26CB}"/>
+            </a:ext>
+          </a:extLst>
+        </p:cNvPr>
+        <p:cNvGrpSpPr/>
+        <p:nvPr/>
+      </p:nvGrpSpPr>
+      <p:grpSpPr>
+        <a:xfrm>
+          <a:off x="0" y="0"/>
+          <a:ext cx="0" cy="0"/>
+          <a:chOff x="0" y="0"/>
+          <a:chExt cx="0" cy="0"/>
+        </a:xfrm>
+      </p:grpSpPr>
+      <p:sp>
+        <p:nvSpPr>
+          <p:cNvPr id="2" name="Slide Image Placeholder 1">
+            <a:extLst>
+              <a:ext uri="{FF2B5EF4-FFF2-40B4-BE49-F238E27FC236}">
+                <a16:creationId xmlns:a16="http://schemas.microsoft.com/office/drawing/2014/main" id="{4A7360AF-B26A-D450-DE75-D1701A38B973}"/>
+              </a:ext>
+            </a:extLst>
+          </p:cNvPr>
+          <p:cNvSpPr>
+            <a:spLocks noGrp="1" noRot="1" noChangeAspect="1"/>
+          </p:cNvSpPr>
+          <p:nvPr>
+            <p:ph type="sldImg"/>
+          </p:nvPr>
+        </p:nvSpPr>
+        <p:spPr/>
+      </p:sp>
+      <p:sp>
+        <p:nvSpPr>
+          <p:cNvPr id="3" name="Notes Placeholder 2">
+            <a:extLst>
+              <a:ext uri="{FF2B5EF4-FFF2-40B4-BE49-F238E27FC236}">
+                <a16:creationId xmlns:a16="http://schemas.microsoft.com/office/drawing/2014/main" id="{FF45ADA6-2679-9BE6-95D7-5E9507BE5D55}"/>
+              </a:ext>
+            </a:extLst>
+          </p:cNvPr>
+          <p:cNvSpPr>
+            <a:spLocks noGrp="1"/>
+          </p:cNvSpPr>
+          <p:nvPr>
+            <p:ph type="body" idx="1"/>
+          </p:nvPr>
+        </p:nvSpPr>
+        <p:spPr/>
+        <p:txBody>
+          <a:bodyPr/>
+          <a:lstStyle/>
+          <a:p>
+            <a:endParaRPr lang="en-US" dirty="0"/>
+          </a:p>
+        </p:txBody>
+      </p:sp>
+      <p:sp>
+        <p:nvSpPr>
+          <p:cNvPr id="4" name="Slide Number Placeholder 3">
+            <a:extLst>
+              <a:ext uri="{FF2B5EF4-FFF2-40B4-BE49-F238E27FC236}">
+                <a16:creationId xmlns:a16="http://schemas.microsoft.com/office/drawing/2014/main" id="{DBFCA32A-57B3-2B43-3251-C9C3AA10231B}"/>
+              </a:ext>
+            </a:extLst>
+          </p:cNvPr>
+          <p:cNvSpPr>
+            <a:spLocks noGrp="1"/>
+          </p:cNvSpPr>
+          <p:nvPr>
+            <p:ph type="sldNum" sz="quarter" idx="5"/>
+          </p:nvPr>
+        </p:nvSpPr>
+        <p:spPr/>
+        <p:txBody>
+          <a:bodyPr/>
+          <a:lstStyle/>
+          <a:p>
+            <a:fld id="{D4B9A9E5-4F7F-4A7D-9DE1-899232329269}" type="slidenum">
+              <a:rPr lang="en-US" smtClean="0"/>
+              <a:t>10</a:t>
+            </a:fld>
+            <a:endParaRPr lang="en-US" dirty="0"/>
+          </a:p>
+        </p:txBody>
+      </p:sp>
+    </p:spTree>
+    <p:extLst>
+      <p:ext uri="{BB962C8B-B14F-4D97-AF65-F5344CB8AC3E}">
+        <p14:creationId xmlns:p14="http://schemas.microsoft.com/office/powerpoint/2010/main" val="484082353"/>
+      </p:ext>
+    </p:extLst>
+  </p:cSld>
+  <p:clrMapOvr>
+    <a:masterClrMapping/>
+  </p:clrMapOvr>
+</p:notes>
+</file>
+
+<file path=ppt/notesSlides/notesSlide11.xml><?xml version="1.0" encoding="utf-8"?>
+<p:notes xmlns:a="http://schemas.openxmlformats.org/drawingml/2006/main" xmlns:r="http://schemas.openxmlformats.org/officeDocument/2006/relationships" xmlns:p="http://schemas.openxmlformats.org/presentationml/2006/main">
+  <p:cSld>
+    <p:spTree>
+      <p:nvGrpSpPr>
+        <p:cNvPr id="1" name="">
+          <a:extLst>
+            <a:ext uri="{FF2B5EF4-FFF2-40B4-BE49-F238E27FC236}">
+              <a16:creationId xmlns:a16="http://schemas.microsoft.com/office/drawing/2014/main" id="{C01BCEC7-2339-2DE5-DFAD-F8145C1EF147}"/>
+            </a:ext>
+          </a:extLst>
+        </p:cNvPr>
+        <p:cNvGrpSpPr/>
+        <p:nvPr/>
+      </p:nvGrpSpPr>
+      <p:grpSpPr>
+        <a:xfrm>
+          <a:off x="0" y="0"/>
+          <a:ext cx="0" cy="0"/>
+          <a:chOff x="0" y="0"/>
+          <a:chExt cx="0" cy="0"/>
+        </a:xfrm>
+      </p:grpSpPr>
+      <p:sp>
+        <p:nvSpPr>
+          <p:cNvPr id="2" name="Slide Image Placeholder 1">
+            <a:extLst>
+              <a:ext uri="{FF2B5EF4-FFF2-40B4-BE49-F238E27FC236}">
+                <a16:creationId xmlns:a16="http://schemas.microsoft.com/office/drawing/2014/main" id="{7409DE68-FB38-0B7A-8484-550B156669C0}"/>
+              </a:ext>
+            </a:extLst>
+          </p:cNvPr>
+          <p:cNvSpPr>
+            <a:spLocks noGrp="1" noRot="1" noChangeAspect="1"/>
+          </p:cNvSpPr>
+          <p:nvPr>
+            <p:ph type="sldImg"/>
+          </p:nvPr>
+        </p:nvSpPr>
+        <p:spPr/>
+      </p:sp>
+      <p:sp>
+        <p:nvSpPr>
+          <p:cNvPr id="3" name="Notes Placeholder 2">
+            <a:extLst>
+              <a:ext uri="{FF2B5EF4-FFF2-40B4-BE49-F238E27FC236}">
+                <a16:creationId xmlns:a16="http://schemas.microsoft.com/office/drawing/2014/main" id="{5E7F4BA3-70A3-7543-781B-1B570065FD51}"/>
+              </a:ext>
+            </a:extLst>
+          </p:cNvPr>
+          <p:cNvSpPr>
+            <a:spLocks noGrp="1"/>
+          </p:cNvSpPr>
+          <p:nvPr>
+            <p:ph type="body" idx="1"/>
+          </p:nvPr>
+        </p:nvSpPr>
+        <p:spPr/>
+        <p:txBody>
+          <a:bodyPr/>
+          <a:lstStyle/>
+          <a:p>
+            <a:endParaRPr lang="en-US" dirty="0"/>
+          </a:p>
+        </p:txBody>
+      </p:sp>
+      <p:sp>
+        <p:nvSpPr>
+          <p:cNvPr id="4" name="Slide Number Placeholder 3">
+            <a:extLst>
+              <a:ext uri="{FF2B5EF4-FFF2-40B4-BE49-F238E27FC236}">
+                <a16:creationId xmlns:a16="http://schemas.microsoft.com/office/drawing/2014/main" id="{747E531F-4C82-7F5E-84D2-A7958AA4FFA2}"/>
+              </a:ext>
+            </a:extLst>
+          </p:cNvPr>
+          <p:cNvSpPr>
+            <a:spLocks noGrp="1"/>
+          </p:cNvSpPr>
+          <p:nvPr>
+            <p:ph type="sldNum" sz="quarter" idx="5"/>
+          </p:nvPr>
+        </p:nvSpPr>
+        <p:spPr/>
+        <p:txBody>
+          <a:bodyPr/>
+          <a:lstStyle/>
+          <a:p>
+            <a:fld id="{D4B9A9E5-4F7F-4A7D-9DE1-899232329269}" type="slidenum">
+              <a:rPr lang="en-US" smtClean="0"/>
+              <a:t>11</a:t>
+            </a:fld>
+            <a:endParaRPr lang="en-US" dirty="0"/>
+          </a:p>
+        </p:txBody>
+      </p:sp>
+    </p:spTree>
+    <p:extLst>
+      <p:ext uri="{BB962C8B-B14F-4D97-AF65-F5344CB8AC3E}">
+        <p14:creationId xmlns:p14="http://schemas.microsoft.com/office/powerpoint/2010/main" val="1153763091"/>
+      </p:ext>
+    </p:extLst>
+  </p:cSld>
+  <p:clrMapOvr>
+    <a:masterClrMapping/>
+  </p:clrMapOvr>
+</p:notes>
+</file>
+
+<file path=ppt/notesSlides/notesSlide12.xml><?xml version="1.0" encoding="utf-8"?>
+<p:notes xmlns:a="http://schemas.openxmlformats.org/drawingml/2006/main" xmlns:r="http://schemas.openxmlformats.org/officeDocument/2006/relationships" xmlns:p="http://schemas.openxmlformats.org/presentationml/2006/main">
+  <p:cSld>
+    <p:spTree>
+      <p:nvGrpSpPr>
+        <p:cNvPr id="1" name="">
+          <a:extLst>
+            <a:ext uri="{FF2B5EF4-FFF2-40B4-BE49-F238E27FC236}">
+              <a16:creationId xmlns:a16="http://schemas.microsoft.com/office/drawing/2014/main" id="{56409A71-435F-7377-9C42-03BE8BDAC597}"/>
+            </a:ext>
+          </a:extLst>
+        </p:cNvPr>
+        <p:cNvGrpSpPr/>
+        <p:nvPr/>
+      </p:nvGrpSpPr>
+      <p:grpSpPr>
+        <a:xfrm>
+          <a:off x="0" y="0"/>
+          <a:ext cx="0" cy="0"/>
+          <a:chOff x="0" y="0"/>
+          <a:chExt cx="0" cy="0"/>
+        </a:xfrm>
+      </p:grpSpPr>
+      <p:sp>
+        <p:nvSpPr>
+          <p:cNvPr id="2" name="Slide Image Placeholder 1">
+            <a:extLst>
+              <a:ext uri="{FF2B5EF4-FFF2-40B4-BE49-F238E27FC236}">
+                <a16:creationId xmlns:a16="http://schemas.microsoft.com/office/drawing/2014/main" id="{44349CF0-FB07-1DCC-B39C-B9F01C13D2EA}"/>
+              </a:ext>
+            </a:extLst>
+          </p:cNvPr>
+          <p:cNvSpPr>
+            <a:spLocks noGrp="1" noRot="1" noChangeAspect="1"/>
+          </p:cNvSpPr>
+          <p:nvPr>
+            <p:ph type="sldImg"/>
+          </p:nvPr>
+        </p:nvSpPr>
+        <p:spPr/>
+      </p:sp>
+      <p:sp>
+        <p:nvSpPr>
+          <p:cNvPr id="3" name="Notes Placeholder 2">
+            <a:extLst>
+              <a:ext uri="{FF2B5EF4-FFF2-40B4-BE49-F238E27FC236}">
+                <a16:creationId xmlns:a16="http://schemas.microsoft.com/office/drawing/2014/main" id="{F72BF646-3C4D-1866-05E0-399B98EAA2BD}"/>
+              </a:ext>
+            </a:extLst>
+          </p:cNvPr>
+          <p:cNvSpPr>
+            <a:spLocks noGrp="1"/>
+          </p:cNvSpPr>
+          <p:nvPr>
+            <p:ph type="body" idx="1"/>
+          </p:nvPr>
+        </p:nvSpPr>
+        <p:spPr/>
+        <p:txBody>
+          <a:bodyPr/>
+          <a:lstStyle/>
+          <a:p>
+            <a:endParaRPr lang="en-US" dirty="0"/>
+          </a:p>
+        </p:txBody>
+      </p:sp>
+      <p:sp>
+        <p:nvSpPr>
+          <p:cNvPr id="4" name="Slide Number Placeholder 3">
+            <a:extLst>
+              <a:ext uri="{FF2B5EF4-FFF2-40B4-BE49-F238E27FC236}">
+                <a16:creationId xmlns:a16="http://schemas.microsoft.com/office/drawing/2014/main" id="{3A834CCA-0D84-7C3B-8031-24BAF4D5E8A2}"/>
+              </a:ext>
+            </a:extLst>
+          </p:cNvPr>
+          <p:cNvSpPr>
+            <a:spLocks noGrp="1"/>
+          </p:cNvSpPr>
+          <p:nvPr>
+            <p:ph type="sldNum" sz="quarter" idx="5"/>
+          </p:nvPr>
+        </p:nvSpPr>
+        <p:spPr/>
+        <p:txBody>
+          <a:bodyPr/>
+          <a:lstStyle/>
+          <a:p>
+            <a:fld id="{D4B9A9E5-4F7F-4A7D-9DE1-899232329269}" type="slidenum">
+              <a:rPr lang="en-US" smtClean="0"/>
+              <a:t>12</a:t>
+            </a:fld>
+            <a:endParaRPr lang="en-US" dirty="0"/>
+          </a:p>
+        </p:txBody>
+      </p:sp>
+    </p:spTree>
+    <p:extLst>
+      <p:ext uri="{BB962C8B-B14F-4D97-AF65-F5344CB8AC3E}">
+        <p14:creationId xmlns:p14="http://schemas.microsoft.com/office/powerpoint/2010/main" val="485781328"/>
+      </p:ext>
+    </p:extLst>
+  </p:cSld>
+  <p:clrMapOvr>
+    <a:masterClrMapping/>
+  </p:clrMapOvr>
+</p:notes>
+</file>
+
+<file path=ppt/notesSlides/notesSlide13.xml><?xml version="1.0" encoding="utf-8"?>
+<p:notes xmlns:a="http://schemas.openxmlformats.org/drawingml/2006/main" xmlns:r="http://schemas.openxmlformats.org/officeDocument/2006/relationships" xmlns:p="http://schemas.openxmlformats.org/presentationml/2006/main">
+  <p:cSld>
+    <p:spTree>
+      <p:nvGrpSpPr>
+        <p:cNvPr id="1" name="">
+          <a:extLst>
+            <a:ext uri="{FF2B5EF4-FFF2-40B4-BE49-F238E27FC236}">
+              <a16:creationId xmlns:a16="http://schemas.microsoft.com/office/drawing/2014/main" id="{621786B8-0DCA-11D2-9D91-57A8FB625784}"/>
+            </a:ext>
+          </a:extLst>
+        </p:cNvPr>
+        <p:cNvGrpSpPr/>
+        <p:nvPr/>
+      </p:nvGrpSpPr>
+      <p:grpSpPr>
+        <a:xfrm>
+          <a:off x="0" y="0"/>
+          <a:ext cx="0" cy="0"/>
+          <a:chOff x="0" y="0"/>
+          <a:chExt cx="0" cy="0"/>
+        </a:xfrm>
+      </p:grpSpPr>
+      <p:sp>
+        <p:nvSpPr>
+          <p:cNvPr id="2" name="Slide Image Placeholder 1">
+            <a:extLst>
+              <a:ext uri="{FF2B5EF4-FFF2-40B4-BE49-F238E27FC236}">
+                <a16:creationId xmlns:a16="http://schemas.microsoft.com/office/drawing/2014/main" id="{31564298-20AF-F476-0D7D-BD9876F02CDF}"/>
+              </a:ext>
+            </a:extLst>
+          </p:cNvPr>
+          <p:cNvSpPr>
+            <a:spLocks noGrp="1" noRot="1" noChangeAspect="1"/>
+          </p:cNvSpPr>
+          <p:nvPr>
+            <p:ph type="sldImg"/>
+          </p:nvPr>
+        </p:nvSpPr>
+        <p:spPr/>
+      </p:sp>
+      <p:sp>
+        <p:nvSpPr>
+          <p:cNvPr id="3" name="Notes Placeholder 2">
+            <a:extLst>
+              <a:ext uri="{FF2B5EF4-FFF2-40B4-BE49-F238E27FC236}">
+                <a16:creationId xmlns:a16="http://schemas.microsoft.com/office/drawing/2014/main" id="{CD76761D-6D5C-5DB1-1D20-18409B246C33}"/>
+              </a:ext>
+            </a:extLst>
+          </p:cNvPr>
+          <p:cNvSpPr>
+            <a:spLocks noGrp="1"/>
+          </p:cNvSpPr>
+          <p:nvPr>
+            <p:ph type="body" idx="1"/>
+          </p:nvPr>
+        </p:nvSpPr>
+        <p:spPr/>
+        <p:txBody>
+          <a:bodyPr/>
+          <a:lstStyle/>
+          <a:p>
+            <a:endParaRPr lang="en-US" dirty="0"/>
+          </a:p>
+        </p:txBody>
+      </p:sp>
+      <p:sp>
+        <p:nvSpPr>
+          <p:cNvPr id="4" name="Slide Number Placeholder 3">
+            <a:extLst>
+              <a:ext uri="{FF2B5EF4-FFF2-40B4-BE49-F238E27FC236}">
+                <a16:creationId xmlns:a16="http://schemas.microsoft.com/office/drawing/2014/main" id="{84251C29-EB3A-A85E-13E3-34AE14544118}"/>
+              </a:ext>
+            </a:extLst>
+          </p:cNvPr>
+          <p:cNvSpPr>
+            <a:spLocks noGrp="1"/>
+          </p:cNvSpPr>
+          <p:nvPr>
+            <p:ph type="sldNum" sz="quarter" idx="5"/>
+          </p:nvPr>
+        </p:nvSpPr>
+        <p:spPr/>
+        <p:txBody>
+          <a:bodyPr/>
+          <a:lstStyle/>
+          <a:p>
+            <a:fld id="{D4B9A9E5-4F7F-4A7D-9DE1-899232329269}" type="slidenum">
+              <a:rPr lang="en-US" smtClean="0"/>
+              <a:t>13</a:t>
+            </a:fld>
+            <a:endParaRPr lang="en-US" dirty="0"/>
+          </a:p>
+        </p:txBody>
+      </p:sp>
+    </p:spTree>
+    <p:extLst>
+      <p:ext uri="{BB962C8B-B14F-4D97-AF65-F5344CB8AC3E}">
+        <p14:creationId xmlns:p14="http://schemas.microsoft.com/office/powerpoint/2010/main" val="950398539"/>
+      </p:ext>
+    </p:extLst>
+  </p:cSld>
+  <p:clrMapOvr>
+    <a:masterClrMapping/>
+  </p:clrMapOvr>
+</p:notes>
+</file>
+
+<file path=ppt/notesSlides/notesSlide14.xml><?xml version="1.0" encoding="utf-8"?>
+<p:notes xmlns:a="http://schemas.openxmlformats.org/drawingml/2006/main" xmlns:r="http://schemas.openxmlformats.org/officeDocument/2006/relationships" xmlns:p="http://schemas.openxmlformats.org/presentationml/2006/main">
+  <p:cSld>
+    <p:spTree>
+      <p:nvGrpSpPr>
         <p:cNvPr id="1" name=""/>
         <p:cNvGrpSpPr/>
         <p:nvPr/>
@@ -840,7 +1284,7 @@
           <a:p>
             <a:fld id="{D4B9A9E5-4F7F-4A7D-9DE1-899232329269}" type="slidenum">
               <a:rPr lang="en-US" smtClean="0"/>
-              <a:t>10</a:t>
+              <a:t>14</a:t>
             </a:fld>
             <a:endParaRPr lang="en-US" dirty="0"/>
           </a:p>
@@ -1335,7 +1779,7 @@
         <p:cNvPr id="1" name="">
           <a:extLst>
             <a:ext uri="{FF2B5EF4-FFF2-40B4-BE49-F238E27FC236}">
-              <a16:creationId xmlns:a16="http://schemas.microsoft.com/office/drawing/2014/main" id="{22F6082E-E693-22FE-0A27-21BD7BBCC817}"/>
+              <a16:creationId xmlns:a16="http://schemas.microsoft.com/office/drawing/2014/main" id="{BB94B6C0-85AE-4E26-BA8E-CA97DF3BF3BA}"/>
             </a:ext>
           </a:extLst>
         </p:cNvPr>
@@ -1355,7 +1799,7 @@
           <p:cNvPr id="2" name="Slide Image Placeholder 1">
             <a:extLst>
               <a:ext uri="{FF2B5EF4-FFF2-40B4-BE49-F238E27FC236}">
-                <a16:creationId xmlns:a16="http://schemas.microsoft.com/office/drawing/2014/main" id="{E076946A-FDA7-E73C-9F1C-2EA6BE230093}"/>
+                <a16:creationId xmlns:a16="http://schemas.microsoft.com/office/drawing/2014/main" id="{FAD56310-03C1-FD4F-537B-23B2EE5B446E}"/>
               </a:ext>
             </a:extLst>
           </p:cNvPr>
@@ -1373,7 +1817,7 @@
           <p:cNvPr id="3" name="Notes Placeholder 2">
             <a:extLst>
               <a:ext uri="{FF2B5EF4-FFF2-40B4-BE49-F238E27FC236}">
-                <a16:creationId xmlns:a16="http://schemas.microsoft.com/office/drawing/2014/main" id="{8F555739-8781-ABB0-FC8F-B32CDF4499FE}"/>
+                <a16:creationId xmlns:a16="http://schemas.microsoft.com/office/drawing/2014/main" id="{303E89D0-D684-2B6B-1C24-B3FFBE6D6646}"/>
               </a:ext>
             </a:extLst>
           </p:cNvPr>
@@ -1389,146 +1833,8 @@
           <a:bodyPr/>
           <a:lstStyle/>
           <a:p>
-            <a:pPr marL="0" indent="0">
-              <a:buNone/>
-            </a:pPr>
-            <a:r>
-              <a:rPr lang="de-DE" dirty="0"/>
-              <a:t>1) - gemessene Arten der Luftverschmutzung: Feinstaub - Partikel &lt;= 10 </a:t>
-            </a:r>
-            <a:r>
-              <a:rPr lang="de-DE" b="1" dirty="0"/>
-              <a:t>µm </a:t>
-            </a:r>
-            <a:r>
-              <a:rPr lang="de-DE" dirty="0"/>
-              <a:t>(PM10), Kohlenmonoxid (CO), Ozon (O3), Schwefeldioxid (SO2), Stickstoffdioxid (NO2), Blei im Feinstaub (PM10PB), Benzo(a)</a:t>
-            </a:r>
-            <a:r>
-              <a:rPr lang="de-DE" dirty="0" err="1"/>
-              <a:t>pyren</a:t>
-            </a:r>
-            <a:r>
-              <a:rPr lang="de-DE" dirty="0"/>
-              <a:t> im Feinstaub (PM10BAP), Benzol (CHB), Feinstaub - Partikel &lt;= 2 </a:t>
-            </a:r>
-            <a:r>
-              <a:rPr lang="de-DE" b="1" dirty="0"/>
-              <a:t>µm </a:t>
-            </a:r>
-            <a:r>
-              <a:rPr lang="de-DE" dirty="0"/>
-              <a:t>(PM2), Arsen im Feinstaub (PM10AS), Cadmium im Feinstaub (PM10CD), Nickel im Feinstaub (PM10NI)</a:t>
-            </a:r>
-            <a:endParaRPr lang="en-DE" dirty="0"/>
-          </a:p>
-          <a:p>
-            <a:pPr marL="0" indent="0">
-              <a:buNone/>
-            </a:pPr>
-            <a:r>
-              <a:rPr lang="de-DE" dirty="0"/>
-              <a:t>2) - Bereiche in denen gemessen wird: alles Bundesländer + UBA</a:t>
-            </a:r>
-            <a:endParaRPr lang="en-DE" dirty="0"/>
-          </a:p>
-          <a:p>
-            <a:pPr marL="0" indent="0">
-              <a:buNone/>
-            </a:pPr>
-            <a:r>
-              <a:rPr lang="de-DE" dirty="0"/>
-              <a:t>3) - Tagesmittel, Ein-Stunden-Mittelwert, Ein-Stunden-Tagesmaxima, Acht-Stunden-Mittelwert, Acht-Stunden-Tagesmaxima, Tagesmittel (stündlich gleitend)</a:t>
-            </a:r>
-            <a:endParaRPr lang="en-DE" dirty="0"/>
-          </a:p>
-          <a:p>
-            <a:pPr marL="0" indent="0">
-              <a:buNone/>
-            </a:pPr>
-            <a:r>
-              <a:rPr lang="de-DE" dirty="0"/>
-              <a:t>4) - Lage der Messstation: städtisches Gebiet, vorstädtisches Gebiet, ländliches Gebiet, ländlich abgelegen, ländliche regional, ländlich stadtnah</a:t>
-            </a:r>
-            <a:endParaRPr lang="en-DE" dirty="0"/>
-          </a:p>
-          <a:p>
-            <a:pPr marL="0" indent="0">
-              <a:buNone/>
-            </a:pPr>
-            <a:r>
-              <a:rPr lang="de-DE" dirty="0"/>
-              <a:t>5) - Stationstypen (was messen sie): Hintergrund, Industrie, Verkehr</a:t>
-            </a:r>
-            <a:endParaRPr lang="en-DE" dirty="0"/>
-          </a:p>
-          <a:p>
-            <a:pPr marL="0" indent="0">
-              <a:buNone/>
-            </a:pPr>
-            <a:r>
-              <a:rPr lang="de-DE" dirty="0"/>
-              <a:t>6) - </a:t>
-            </a:r>
-            <a:r>
-              <a:rPr lang="de-DE" dirty="0" err="1"/>
-              <a:t>Thresholds</a:t>
-            </a:r>
-            <a:r>
-              <a:rPr lang="de-DE" dirty="0"/>
-              <a:t> (Klassifizierungsstufen für die Luftverschmutzung): von 0 bis 4</a:t>
-            </a:r>
-            <a:endParaRPr lang="en-DE" dirty="0"/>
-          </a:p>
-          <a:p>
-            <a:pPr marL="0" indent="0">
-              <a:buNone/>
-            </a:pPr>
-            <a:r>
-              <a:rPr lang="de-DE" dirty="0"/>
-              <a:t>7) - Ausgabe wann bestimmte Verschmutzungsgrenzen überschritten wurden</a:t>
-            </a:r>
-            <a:endParaRPr lang="en-DE" dirty="0"/>
-          </a:p>
-          <a:p>
-            <a:pPr marL="0" indent="0">
-              <a:buNone/>
-            </a:pPr>
-            <a:r>
-              <a:rPr lang="de-DE" dirty="0"/>
-              <a:t>8) - viele der oben genannten Kriterien vereint unter einer Suchanfrage mit zeitlicher Abgrenzungsmöglichkeit</a:t>
-            </a:r>
-            <a:endParaRPr lang="en-DE" dirty="0"/>
-          </a:p>
-          <a:p>
             <a:endParaRPr lang="en-US" dirty="0"/>
           </a:p>
-          <a:p>
-            <a:pPr marL="0" marR="0" lvl="0" indent="0" algn="l" defTabSz="914400" rtl="0" eaLnBrk="1" fontAlgn="auto" latinLnBrk="0" hangingPunct="1">
-              <a:lnSpc>
-                <a:spcPct val="100000"/>
-              </a:lnSpc>
-              <a:spcBef>
-                <a:spcPts val="0"/>
-              </a:spcBef>
-              <a:spcAft>
-                <a:spcPts val="0"/>
-              </a:spcAft>
-              <a:buClrTx/>
-              <a:buSzTx/>
-              <a:buFontTx/>
-              <a:buNone/>
-              <a:tabLst/>
-              <a:defRPr/>
-            </a:pPr>
-            <a:r>
-              <a:rPr lang="en-US" dirty="0"/>
-              <a:t>Measured types of air pollution: particulate matter ≤ 10 µm (PM10), carbon monoxide (CO), ozone (O3), sulfur dioxide (SO2), nitrogen dioxide (NO2), lead in particulate matter (PM10Pb), benzo(a)pyrene in particulate matter (PM10BaP), benzene (C6H6), particulate matter ≤ 2.5 µm (PM2.5), arsenic in particulate matter (PM10As), cadmium in particulate matter (PM10Cd), nickel in particulate matter (PM10Ni)</a:t>
-            </a:r>
-          </a:p>
-          <a:p>
-            <a:endParaRPr lang="en-US" dirty="0"/>
-          </a:p>
         </p:txBody>
       </p:sp>
       <p:sp>
@@ -1536,7 +1842,7 @@
           <p:cNvPr id="4" name="Slide Number Placeholder 3">
             <a:extLst>
               <a:ext uri="{FF2B5EF4-FFF2-40B4-BE49-F238E27FC236}">
-                <a16:creationId xmlns:a16="http://schemas.microsoft.com/office/drawing/2014/main" id="{0DF4691E-A526-4780-0C59-D80DD07C49C0}"/>
+                <a16:creationId xmlns:a16="http://schemas.microsoft.com/office/drawing/2014/main" id="{A6F8EDEB-877F-A9DD-318D-9B23C70D388A}"/>
               </a:ext>
             </a:extLst>
           </p:cNvPr>
@@ -1563,7 +1869,7 @@
     </p:spTree>
     <p:extLst>
       <p:ext uri="{BB962C8B-B14F-4D97-AF65-F5344CB8AC3E}">
-        <p14:creationId xmlns:p14="http://schemas.microsoft.com/office/powerpoint/2010/main" val="2629324167"/>
+        <p14:creationId xmlns:p14="http://schemas.microsoft.com/office/powerpoint/2010/main" val="2684238389"/>
       </p:ext>
     </p:extLst>
   </p:cSld>
@@ -1581,7 +1887,7 @@
         <p:cNvPr id="1" name="">
           <a:extLst>
             <a:ext uri="{FF2B5EF4-FFF2-40B4-BE49-F238E27FC236}">
-              <a16:creationId xmlns:a16="http://schemas.microsoft.com/office/drawing/2014/main" id="{1A8B1996-41EC-3F2A-0165-0466128922F2}"/>
+              <a16:creationId xmlns:a16="http://schemas.microsoft.com/office/drawing/2014/main" id="{9C554999-4578-D4CE-9476-CAB0799374F4}"/>
             </a:ext>
           </a:extLst>
         </p:cNvPr>
@@ -1601,7 +1907,7 @@
           <p:cNvPr id="2" name="Slide Image Placeholder 1">
             <a:extLst>
               <a:ext uri="{FF2B5EF4-FFF2-40B4-BE49-F238E27FC236}">
-                <a16:creationId xmlns:a16="http://schemas.microsoft.com/office/drawing/2014/main" id="{D7DFF5D0-2AC1-5005-31CA-177836B2926A}"/>
+                <a16:creationId xmlns:a16="http://schemas.microsoft.com/office/drawing/2014/main" id="{EFA1CDCD-6B4D-034D-6447-4F63CC102E20}"/>
               </a:ext>
             </a:extLst>
           </p:cNvPr>
@@ -1619,7 +1925,7 @@
           <p:cNvPr id="3" name="Notes Placeholder 2">
             <a:extLst>
               <a:ext uri="{FF2B5EF4-FFF2-40B4-BE49-F238E27FC236}">
-                <a16:creationId xmlns:a16="http://schemas.microsoft.com/office/drawing/2014/main" id="{2B05B934-CE18-9B32-6ACB-292DE5C52A11}"/>
+                <a16:creationId xmlns:a16="http://schemas.microsoft.com/office/drawing/2014/main" id="{851B6255-B476-6E1E-2EE9-303379717A02}"/>
               </a:ext>
             </a:extLst>
           </p:cNvPr>
@@ -1635,146 +1941,8 @@
           <a:bodyPr/>
           <a:lstStyle/>
           <a:p>
-            <a:pPr marL="0" indent="0">
-              <a:buNone/>
-            </a:pPr>
-            <a:r>
-              <a:rPr lang="de-DE" dirty="0"/>
-              <a:t>1) - gemessene Arten der Luftverschmutzung: Feinstaub - Partikel &lt;= 10 </a:t>
-            </a:r>
-            <a:r>
-              <a:rPr lang="de-DE" b="1" dirty="0"/>
-              <a:t>µm </a:t>
-            </a:r>
-            <a:r>
-              <a:rPr lang="de-DE" dirty="0"/>
-              <a:t>(PM10), Kohlenmonoxid (CO), Ozon (O3), Schwefeldioxid (SO2), Stickstoffdioxid (NO2), Blei im Feinstaub (PM10PB), Benzo(a)</a:t>
-            </a:r>
-            <a:r>
-              <a:rPr lang="de-DE" dirty="0" err="1"/>
-              <a:t>pyren</a:t>
-            </a:r>
-            <a:r>
-              <a:rPr lang="de-DE" dirty="0"/>
-              <a:t> im Feinstaub (PM10BAP), Benzol (CHB), Feinstaub - Partikel &lt;= 2 </a:t>
-            </a:r>
-            <a:r>
-              <a:rPr lang="de-DE" b="1" dirty="0"/>
-              <a:t>µm </a:t>
-            </a:r>
-            <a:r>
-              <a:rPr lang="de-DE" dirty="0"/>
-              <a:t>(PM2), Arsen im Feinstaub (PM10AS), Cadmium im Feinstaub (PM10CD), Nickel im Feinstaub (PM10NI)</a:t>
-            </a:r>
-            <a:endParaRPr lang="en-DE" dirty="0"/>
-          </a:p>
-          <a:p>
-            <a:pPr marL="0" indent="0">
-              <a:buNone/>
-            </a:pPr>
-            <a:r>
-              <a:rPr lang="de-DE" dirty="0"/>
-              <a:t>2) - Bereiche in denen gemessen wird: alles Bundesländer + UBA</a:t>
-            </a:r>
-            <a:endParaRPr lang="en-DE" dirty="0"/>
-          </a:p>
-          <a:p>
-            <a:pPr marL="0" indent="0">
-              <a:buNone/>
-            </a:pPr>
-            <a:r>
-              <a:rPr lang="de-DE" dirty="0"/>
-              <a:t>3) - Tagesmittel, Ein-Stunden-Mittelwert, Ein-Stunden-Tagesmaxima, Acht-Stunden-Mittelwert, Acht-Stunden-Tagesmaxima, Tagesmittel (stündlich gleitend)</a:t>
-            </a:r>
-            <a:endParaRPr lang="en-DE" dirty="0"/>
-          </a:p>
-          <a:p>
-            <a:pPr marL="0" indent="0">
-              <a:buNone/>
-            </a:pPr>
-            <a:r>
-              <a:rPr lang="de-DE" dirty="0"/>
-              <a:t>4) - Lage der Messstation: städtisches Gebiet, vorstädtisches Gebiet, ländliches Gebiet, ländlich abgelegen, ländliche regional, ländlich stadtnah</a:t>
-            </a:r>
-            <a:endParaRPr lang="en-DE" dirty="0"/>
-          </a:p>
-          <a:p>
-            <a:pPr marL="0" indent="0">
-              <a:buNone/>
-            </a:pPr>
-            <a:r>
-              <a:rPr lang="de-DE" dirty="0"/>
-              <a:t>5) - Stationstypen (was messen sie): Hintergrund, Industrie, Verkehr</a:t>
-            </a:r>
-            <a:endParaRPr lang="en-DE" dirty="0"/>
-          </a:p>
-          <a:p>
-            <a:pPr marL="0" indent="0">
-              <a:buNone/>
-            </a:pPr>
-            <a:r>
-              <a:rPr lang="de-DE" dirty="0"/>
-              <a:t>6) - </a:t>
-            </a:r>
-            <a:r>
-              <a:rPr lang="de-DE" dirty="0" err="1"/>
-              <a:t>Thresholds</a:t>
-            </a:r>
-            <a:r>
-              <a:rPr lang="de-DE" dirty="0"/>
-              <a:t> (Klassifizierungsstufen für die Luftverschmutzung): von 0 bis 4</a:t>
-            </a:r>
-            <a:endParaRPr lang="en-DE" dirty="0"/>
-          </a:p>
-          <a:p>
-            <a:pPr marL="0" indent="0">
-              <a:buNone/>
-            </a:pPr>
-            <a:r>
-              <a:rPr lang="de-DE" dirty="0"/>
-              <a:t>7) - Ausgabe wann bestimmte Verschmutzungsgrenzen überschritten wurden</a:t>
-            </a:r>
-            <a:endParaRPr lang="en-DE" dirty="0"/>
-          </a:p>
-          <a:p>
-            <a:pPr marL="0" indent="0">
-              <a:buNone/>
-            </a:pPr>
-            <a:r>
-              <a:rPr lang="de-DE" dirty="0"/>
-              <a:t>8) - viele der oben genannten Kriterien vereint unter einer Suchanfrage mit zeitlicher Abgrenzungsmöglichkeit</a:t>
-            </a:r>
-            <a:endParaRPr lang="en-DE" dirty="0"/>
-          </a:p>
-          <a:p>
             <a:endParaRPr lang="en-US" dirty="0"/>
           </a:p>
-          <a:p>
-            <a:pPr marL="0" marR="0" lvl="0" indent="0" algn="l" defTabSz="914400" rtl="0" eaLnBrk="1" fontAlgn="auto" latinLnBrk="0" hangingPunct="1">
-              <a:lnSpc>
-                <a:spcPct val="100000"/>
-              </a:lnSpc>
-              <a:spcBef>
-                <a:spcPts val="0"/>
-              </a:spcBef>
-              <a:spcAft>
-                <a:spcPts val="0"/>
-              </a:spcAft>
-              <a:buClrTx/>
-              <a:buSzTx/>
-              <a:buFontTx/>
-              <a:buNone/>
-              <a:tabLst/>
-              <a:defRPr/>
-            </a:pPr>
-            <a:r>
-              <a:rPr lang="en-US" dirty="0"/>
-              <a:t>Measured types of air pollution: particulate matter ≤ 10 µm (PM10), carbon monoxide (CO), ozone (O3), sulfur dioxide (SO2), nitrogen dioxide (NO2), lead in particulate matter (PM10Pb), benzo(a)pyrene in particulate matter (PM10BaP), benzene (C6H6), particulate matter ≤ 2.5 µm (PM2.5), arsenic in particulate matter (PM10As), cadmium in particulate matter (PM10Cd), nickel in particulate matter (PM10Ni)</a:t>
-            </a:r>
-          </a:p>
-          <a:p>
-            <a:endParaRPr lang="en-US" dirty="0"/>
-          </a:p>
         </p:txBody>
       </p:sp>
       <p:sp>
@@ -1782,7 +1950,7 @@
           <p:cNvPr id="4" name="Slide Number Placeholder 3">
             <a:extLst>
               <a:ext uri="{FF2B5EF4-FFF2-40B4-BE49-F238E27FC236}">
-                <a16:creationId xmlns:a16="http://schemas.microsoft.com/office/drawing/2014/main" id="{C45716CF-D72B-E60D-29BF-9E3747F66DCA}"/>
+                <a16:creationId xmlns:a16="http://schemas.microsoft.com/office/drawing/2014/main" id="{F6CB1B28-8496-84D1-C102-2BB00D0497D0}"/>
               </a:ext>
             </a:extLst>
           </p:cNvPr>
@@ -1809,7 +1977,7 @@
     </p:spTree>
     <p:extLst>
       <p:ext uri="{BB962C8B-B14F-4D97-AF65-F5344CB8AC3E}">
-        <p14:creationId xmlns:p14="http://schemas.microsoft.com/office/powerpoint/2010/main" val="3263378969"/>
+        <p14:creationId xmlns:p14="http://schemas.microsoft.com/office/powerpoint/2010/main" val="580281959"/>
       </p:ext>
     </p:extLst>
   </p:cSld>
@@ -1827,7 +1995,7 @@
         <p:cNvPr id="1" name="">
           <a:extLst>
             <a:ext uri="{FF2B5EF4-FFF2-40B4-BE49-F238E27FC236}">
-              <a16:creationId xmlns:a16="http://schemas.microsoft.com/office/drawing/2014/main" id="{621786B8-0DCA-11D2-9D91-57A8FB625784}"/>
+              <a16:creationId xmlns:a16="http://schemas.microsoft.com/office/drawing/2014/main" id="{22F6082E-E693-22FE-0A27-21BD7BBCC817}"/>
             </a:ext>
           </a:extLst>
         </p:cNvPr>
@@ -1847,7 +2015,7 @@
           <p:cNvPr id="2" name="Slide Image Placeholder 1">
             <a:extLst>
               <a:ext uri="{FF2B5EF4-FFF2-40B4-BE49-F238E27FC236}">
-                <a16:creationId xmlns:a16="http://schemas.microsoft.com/office/drawing/2014/main" id="{31564298-20AF-F476-0D7D-BD9876F02CDF}"/>
+                <a16:creationId xmlns:a16="http://schemas.microsoft.com/office/drawing/2014/main" id="{E076946A-FDA7-E73C-9F1C-2EA6BE230093}"/>
               </a:ext>
             </a:extLst>
           </p:cNvPr>
@@ -1865,7 +2033,7 @@
           <p:cNvPr id="3" name="Notes Placeholder 2">
             <a:extLst>
               <a:ext uri="{FF2B5EF4-FFF2-40B4-BE49-F238E27FC236}">
-                <a16:creationId xmlns:a16="http://schemas.microsoft.com/office/drawing/2014/main" id="{CD76761D-6D5C-5DB1-1D20-18409B246C33}"/>
+                <a16:creationId xmlns:a16="http://schemas.microsoft.com/office/drawing/2014/main" id="{8F555739-8781-ABB0-FC8F-B32CDF4499FE}"/>
               </a:ext>
             </a:extLst>
           </p:cNvPr>
@@ -1881,146 +2049,8 @@
           <a:bodyPr/>
           <a:lstStyle/>
           <a:p>
-            <a:pPr marL="0" indent="0">
-              <a:buNone/>
-            </a:pPr>
-            <a:r>
-              <a:rPr lang="de-DE" dirty="0"/>
-              <a:t>1) - gemessene Arten der Luftverschmutzung: Feinstaub - Partikel &lt;= 10 </a:t>
-            </a:r>
-            <a:r>
-              <a:rPr lang="de-DE" b="1" dirty="0"/>
-              <a:t>µm </a:t>
-            </a:r>
-            <a:r>
-              <a:rPr lang="de-DE" dirty="0"/>
-              <a:t>(PM10), Kohlenmonoxid (CO), Ozon (O3), Schwefeldioxid (SO2), Stickstoffdioxid (NO2), Blei im Feinstaub (PM10PB), Benzo(a)</a:t>
-            </a:r>
-            <a:r>
-              <a:rPr lang="de-DE" dirty="0" err="1"/>
-              <a:t>pyren</a:t>
-            </a:r>
-            <a:r>
-              <a:rPr lang="de-DE" dirty="0"/>
-              <a:t> im Feinstaub (PM10BAP), Benzol (CHB), Feinstaub - Partikel &lt;= 2 </a:t>
-            </a:r>
-            <a:r>
-              <a:rPr lang="de-DE" b="1" dirty="0"/>
-              <a:t>µm </a:t>
-            </a:r>
-            <a:r>
-              <a:rPr lang="de-DE" dirty="0"/>
-              <a:t>(PM2), Arsen im Feinstaub (PM10AS), Cadmium im Feinstaub (PM10CD), Nickel im Feinstaub (PM10NI)</a:t>
-            </a:r>
-            <a:endParaRPr lang="en-DE" dirty="0"/>
-          </a:p>
-          <a:p>
-            <a:pPr marL="0" indent="0">
-              <a:buNone/>
-            </a:pPr>
-            <a:r>
-              <a:rPr lang="de-DE" dirty="0"/>
-              <a:t>2) - Bereiche in denen gemessen wird: alles Bundesländer + UBA</a:t>
-            </a:r>
-            <a:endParaRPr lang="en-DE" dirty="0"/>
-          </a:p>
-          <a:p>
-            <a:pPr marL="0" indent="0">
-              <a:buNone/>
-            </a:pPr>
-            <a:r>
-              <a:rPr lang="de-DE" dirty="0"/>
-              <a:t>3) - Tagesmittel, Ein-Stunden-Mittelwert, Ein-Stunden-Tagesmaxima, Acht-Stunden-Mittelwert, Acht-Stunden-Tagesmaxima, Tagesmittel (stündlich gleitend)</a:t>
-            </a:r>
-            <a:endParaRPr lang="en-DE" dirty="0"/>
-          </a:p>
-          <a:p>
-            <a:pPr marL="0" indent="0">
-              <a:buNone/>
-            </a:pPr>
-            <a:r>
-              <a:rPr lang="de-DE" dirty="0"/>
-              <a:t>4) - Lage der Messstation: städtisches Gebiet, vorstädtisches Gebiet, ländliches Gebiet, ländlich abgelegen, ländliche regional, ländlich stadtnah</a:t>
-            </a:r>
-            <a:endParaRPr lang="en-DE" dirty="0"/>
-          </a:p>
-          <a:p>
-            <a:pPr marL="0" indent="0">
-              <a:buNone/>
-            </a:pPr>
-            <a:r>
-              <a:rPr lang="de-DE" dirty="0"/>
-              <a:t>5) - Stationstypen (was messen sie): Hintergrund, Industrie, Verkehr</a:t>
-            </a:r>
-            <a:endParaRPr lang="en-DE" dirty="0"/>
-          </a:p>
-          <a:p>
-            <a:pPr marL="0" indent="0">
-              <a:buNone/>
-            </a:pPr>
-            <a:r>
-              <a:rPr lang="de-DE" dirty="0"/>
-              <a:t>6) - </a:t>
-            </a:r>
-            <a:r>
-              <a:rPr lang="de-DE" dirty="0" err="1"/>
-              <a:t>Thresholds</a:t>
-            </a:r>
-            <a:r>
-              <a:rPr lang="de-DE" dirty="0"/>
-              <a:t> (Klassifizierungsstufen für die Luftverschmutzung): von 0 bis 4</a:t>
-            </a:r>
-            <a:endParaRPr lang="en-DE" dirty="0"/>
-          </a:p>
-          <a:p>
-            <a:pPr marL="0" indent="0">
-              <a:buNone/>
-            </a:pPr>
-            <a:r>
-              <a:rPr lang="de-DE" dirty="0"/>
-              <a:t>7) - Ausgabe wann bestimmte Verschmutzungsgrenzen überschritten wurden</a:t>
-            </a:r>
-            <a:endParaRPr lang="en-DE" dirty="0"/>
-          </a:p>
-          <a:p>
-            <a:pPr marL="0" indent="0">
-              <a:buNone/>
-            </a:pPr>
-            <a:r>
-              <a:rPr lang="de-DE" dirty="0"/>
-              <a:t>8) - viele der oben genannten Kriterien vereint unter einer Suchanfrage mit zeitlicher Abgrenzungsmöglichkeit</a:t>
-            </a:r>
-            <a:endParaRPr lang="en-DE" dirty="0"/>
-          </a:p>
-          <a:p>
             <a:endParaRPr lang="en-US" dirty="0"/>
           </a:p>
-          <a:p>
-            <a:pPr marL="0" marR="0" lvl="0" indent="0" algn="l" defTabSz="914400" rtl="0" eaLnBrk="1" fontAlgn="auto" latinLnBrk="0" hangingPunct="1">
-              <a:lnSpc>
-                <a:spcPct val="100000"/>
-              </a:lnSpc>
-              <a:spcBef>
-                <a:spcPts val="0"/>
-              </a:spcBef>
-              <a:spcAft>
-                <a:spcPts val="0"/>
-              </a:spcAft>
-              <a:buClrTx/>
-              <a:buSzTx/>
-              <a:buFontTx/>
-              <a:buNone/>
-              <a:tabLst/>
-              <a:defRPr/>
-            </a:pPr>
-            <a:r>
-              <a:rPr lang="en-US" dirty="0"/>
-              <a:t>Measured types of air pollution: particulate matter ≤ 10 µm (PM10), carbon monoxide (CO), ozone (O3), sulfur dioxide (SO2), nitrogen dioxide (NO2), lead in particulate matter (PM10Pb), benzo(a)pyrene in particulate matter (PM10BaP), benzene (C6H6), particulate matter ≤ 2.5 µm (PM2.5), arsenic in particulate matter (PM10As), cadmium in particulate matter (PM10Cd), nickel in particulate matter (PM10Ni)</a:t>
-            </a:r>
-          </a:p>
-          <a:p>
-            <a:endParaRPr lang="en-US" dirty="0"/>
-          </a:p>
         </p:txBody>
       </p:sp>
       <p:sp>
@@ -2028,7 +2058,7 @@
           <p:cNvPr id="4" name="Slide Number Placeholder 3">
             <a:extLst>
               <a:ext uri="{FF2B5EF4-FFF2-40B4-BE49-F238E27FC236}">
-                <a16:creationId xmlns:a16="http://schemas.microsoft.com/office/drawing/2014/main" id="{84251C29-EB3A-A85E-13E3-34AE14544118}"/>
+                <a16:creationId xmlns:a16="http://schemas.microsoft.com/office/drawing/2014/main" id="{0DF4691E-A526-4780-0C59-D80DD07C49C0}"/>
               </a:ext>
             </a:extLst>
           </p:cNvPr>
@@ -2055,7 +2085,7 @@
     </p:spTree>
     <p:extLst>
       <p:ext uri="{BB962C8B-B14F-4D97-AF65-F5344CB8AC3E}">
-        <p14:creationId xmlns:p14="http://schemas.microsoft.com/office/powerpoint/2010/main" val="950398539"/>
+        <p14:creationId xmlns:p14="http://schemas.microsoft.com/office/powerpoint/2010/main" val="2629324167"/>
       </p:ext>
     </p:extLst>
   </p:cSld>
@@ -6973,6 +7003,802 @@
 <file path=ppt/slides/slide10.xml><?xml version="1.0" encoding="utf-8"?>
 <p:sld xmlns:a="http://schemas.openxmlformats.org/drawingml/2006/main" xmlns:r="http://schemas.openxmlformats.org/officeDocument/2006/relationships" xmlns:p="http://schemas.openxmlformats.org/presentationml/2006/main">
   <p:cSld>
+    <p:spTree>
+      <p:nvGrpSpPr>
+        <p:cNvPr id="1" name="">
+          <a:extLst>
+            <a:ext uri="{FF2B5EF4-FFF2-40B4-BE49-F238E27FC236}">
+              <a16:creationId xmlns:a16="http://schemas.microsoft.com/office/drawing/2014/main" id="{1BF7CF4F-2A07-423D-890E-D457F4314ABB}"/>
+            </a:ext>
+          </a:extLst>
+        </p:cNvPr>
+        <p:cNvGrpSpPr/>
+        <p:nvPr/>
+      </p:nvGrpSpPr>
+      <p:grpSpPr>
+        <a:xfrm>
+          <a:off x="0" y="0"/>
+          <a:ext cx="0" cy="0"/>
+          <a:chOff x="0" y="0"/>
+          <a:chExt cx="0" cy="0"/>
+        </a:xfrm>
+      </p:grpSpPr>
+      <p:sp>
+        <p:nvSpPr>
+          <p:cNvPr id="2" name="Title 1">
+            <a:extLst>
+              <a:ext uri="{FF2B5EF4-FFF2-40B4-BE49-F238E27FC236}">
+                <a16:creationId xmlns:a16="http://schemas.microsoft.com/office/drawing/2014/main" id="{7055EF3D-3251-6F40-0499-740F835D8CB0}"/>
+              </a:ext>
+            </a:extLst>
+          </p:cNvPr>
+          <p:cNvSpPr>
+            <a:spLocks noGrp="1"/>
+          </p:cNvSpPr>
+          <p:nvPr>
+            <p:ph type="title"/>
+          </p:nvPr>
+        </p:nvSpPr>
+        <p:spPr>
+          <a:xfrm>
+            <a:off x="914399" y="365125"/>
+            <a:ext cx="9719354" cy="1646555"/>
+          </a:xfrm>
+        </p:spPr>
+        <p:txBody>
+          <a:bodyPr/>
+          <a:lstStyle/>
+          <a:p>
+            <a:r>
+              <a:rPr lang="en-US" dirty="0"/>
+              <a:t>Air Pollution</a:t>
+            </a:r>
+            <a:r>
+              <a:rPr lang="en-US" sz="3200" dirty="0"/>
+              <a:t> – Weather API</a:t>
+            </a:r>
+          </a:p>
+        </p:txBody>
+      </p:sp>
+      <p:sp>
+        <p:nvSpPr>
+          <p:cNvPr id="4" name="Slide Number Placeholder 3">
+            <a:extLst>
+              <a:ext uri="{FF2B5EF4-FFF2-40B4-BE49-F238E27FC236}">
+                <a16:creationId xmlns:a16="http://schemas.microsoft.com/office/drawing/2014/main" id="{D41277AB-0FD2-FAB3-E2B4-3B66FF4BD0E0}"/>
+              </a:ext>
+            </a:extLst>
+          </p:cNvPr>
+          <p:cNvSpPr>
+            <a:spLocks noGrp="1"/>
+          </p:cNvSpPr>
+          <p:nvPr>
+            <p:ph type="sldNum" sz="quarter" idx="4"/>
+          </p:nvPr>
+        </p:nvSpPr>
+        <p:spPr/>
+        <p:txBody>
+          <a:bodyPr/>
+          <a:lstStyle/>
+          <a:p>
+            <a:fld id="{B5CEABB6-07DC-46E8-9B57-56EC44A396E5}" type="slidenum">
+              <a:rPr lang="en-US" smtClean="0"/>
+              <a:pPr/>
+              <a:t>10</a:t>
+            </a:fld>
+            <a:endParaRPr lang="en-US" dirty="0"/>
+          </a:p>
+        </p:txBody>
+      </p:sp>
+      <p:pic>
+        <p:nvPicPr>
+          <p:cNvPr id="7" name="Inhaltsplatzhalter 6">
+            <a:extLst>
+              <a:ext uri="{FF2B5EF4-FFF2-40B4-BE49-F238E27FC236}">
+                <a16:creationId xmlns:a16="http://schemas.microsoft.com/office/drawing/2014/main" id="{1B7BAD73-201C-62D7-4E27-D296AA60AF5C}"/>
+              </a:ext>
+            </a:extLst>
+          </p:cNvPr>
+          <p:cNvPicPr>
+            <a:picLocks noGrp="1" noChangeAspect="1"/>
+          </p:cNvPicPr>
+          <p:nvPr>
+            <p:ph sz="quarter" idx="10"/>
+          </p:nvPr>
+        </p:nvPicPr>
+        <p:blipFill>
+          <a:blip r:embed="rId3"/>
+          <a:stretch>
+            <a:fillRect/>
+          </a:stretch>
+        </p:blipFill>
+        <p:spPr>
+          <a:xfrm>
+            <a:off x="1545465" y="2114823"/>
+            <a:ext cx="5158409" cy="4131431"/>
+          </a:xfrm>
+          <a:prstGeom prst="rect">
+            <a:avLst/>
+          </a:prstGeom>
+        </p:spPr>
+      </p:pic>
+      <p:pic>
+        <p:nvPicPr>
+          <p:cNvPr id="9" name="Grafik 8">
+            <a:extLst>
+              <a:ext uri="{FF2B5EF4-FFF2-40B4-BE49-F238E27FC236}">
+                <a16:creationId xmlns:a16="http://schemas.microsoft.com/office/drawing/2014/main" id="{296A5D9D-7385-9EBF-CF14-81C17865585E}"/>
+              </a:ext>
+            </a:extLst>
+          </p:cNvPr>
+          <p:cNvPicPr>
+            <a:picLocks noChangeAspect="1"/>
+          </p:cNvPicPr>
+          <p:nvPr/>
+        </p:nvPicPr>
+        <p:blipFill>
+          <a:blip r:embed="rId4"/>
+          <a:stretch>
+            <a:fillRect/>
+          </a:stretch>
+        </p:blipFill>
+        <p:spPr>
+          <a:xfrm>
+            <a:off x="7684256" y="1013791"/>
+            <a:ext cx="2422723" cy="5232463"/>
+          </a:xfrm>
+          <a:prstGeom prst="rect">
+            <a:avLst/>
+          </a:prstGeom>
+        </p:spPr>
+      </p:pic>
+    </p:spTree>
+    <p:extLst>
+      <p:ext uri="{BB962C8B-B14F-4D97-AF65-F5344CB8AC3E}">
+        <p14:creationId xmlns:p14="http://schemas.microsoft.com/office/powerpoint/2010/main" val="2225908012"/>
+      </p:ext>
+    </p:extLst>
+  </p:cSld>
+  <p:clrMapOvr>
+    <a:masterClrMapping/>
+  </p:clrMapOvr>
+</p:sld>
+</file>
+
+<file path=ppt/slides/slide11.xml><?xml version="1.0" encoding="utf-8"?>
+<p:sld xmlns:a="http://schemas.openxmlformats.org/drawingml/2006/main" xmlns:r="http://schemas.openxmlformats.org/officeDocument/2006/relationships" xmlns:p="http://schemas.openxmlformats.org/presentationml/2006/main">
+  <p:cSld>
+    <p:spTree>
+      <p:nvGrpSpPr>
+        <p:cNvPr id="1" name="">
+          <a:extLst>
+            <a:ext uri="{FF2B5EF4-FFF2-40B4-BE49-F238E27FC236}">
+              <a16:creationId xmlns:a16="http://schemas.microsoft.com/office/drawing/2014/main" id="{323CB2B4-95AF-3A81-361C-E13874F2AE7C}"/>
+            </a:ext>
+          </a:extLst>
+        </p:cNvPr>
+        <p:cNvGrpSpPr/>
+        <p:nvPr/>
+      </p:nvGrpSpPr>
+      <p:grpSpPr>
+        <a:xfrm>
+          <a:off x="0" y="0"/>
+          <a:ext cx="0" cy="0"/>
+          <a:chOff x="0" y="0"/>
+          <a:chExt cx="0" cy="0"/>
+        </a:xfrm>
+      </p:grpSpPr>
+      <p:pic>
+        <p:nvPicPr>
+          <p:cNvPr id="3" name="Grafik 2" descr="OpenAQ Platform · GitHub">
+            <a:extLst>
+              <a:ext uri="{FF2B5EF4-FFF2-40B4-BE49-F238E27FC236}">
+                <a16:creationId xmlns:a16="http://schemas.microsoft.com/office/drawing/2014/main" id="{F28B6ED5-4047-584A-9402-DEE66D488419}"/>
+              </a:ext>
+            </a:extLst>
+          </p:cNvPr>
+          <p:cNvPicPr>
+            <a:picLocks noChangeAspect="1"/>
+          </p:cNvPicPr>
+          <p:nvPr/>
+        </p:nvPicPr>
+        <p:blipFill>
+          <a:blip r:embed="rId3"/>
+          <a:srcRect r="5464" b="1829"/>
+          <a:stretch>
+            <a:fillRect/>
+          </a:stretch>
+        </p:blipFill>
+        <p:spPr>
+          <a:xfrm>
+            <a:off x="2633785" y="1304122"/>
+            <a:ext cx="1465981" cy="1417430"/>
+          </a:xfrm>
+          <a:prstGeom prst="rect">
+            <a:avLst/>
+          </a:prstGeom>
+        </p:spPr>
+      </p:pic>
+      <p:sp>
+        <p:nvSpPr>
+          <p:cNvPr id="2" name="Title 1">
+            <a:extLst>
+              <a:ext uri="{FF2B5EF4-FFF2-40B4-BE49-F238E27FC236}">
+                <a16:creationId xmlns:a16="http://schemas.microsoft.com/office/drawing/2014/main" id="{A44189FC-2161-E5E8-180D-415F0F76C360}"/>
+              </a:ext>
+            </a:extLst>
+          </p:cNvPr>
+          <p:cNvSpPr>
+            <a:spLocks noGrp="1"/>
+          </p:cNvSpPr>
+          <p:nvPr>
+            <p:ph type="title"/>
+          </p:nvPr>
+        </p:nvSpPr>
+        <p:spPr>
+          <a:xfrm>
+            <a:off x="914399" y="365125"/>
+            <a:ext cx="10505662" cy="1646555"/>
+          </a:xfrm>
+        </p:spPr>
+        <p:txBody>
+          <a:bodyPr/>
+          <a:lstStyle/>
+          <a:p>
+            <a:r>
+              <a:rPr lang="en-US" dirty="0"/>
+              <a:t>Air Pollution</a:t>
+            </a:r>
+            <a:r>
+              <a:rPr lang="en-US" sz="3200" dirty="0"/>
+              <a:t> – </a:t>
+            </a:r>
+            <a:r>
+              <a:rPr lang="en-US" dirty="0"/>
+              <a:t>comparison to other countries</a:t>
+            </a:r>
+            <a:endParaRPr lang="en-US" sz="3200" dirty="0"/>
+          </a:p>
+        </p:txBody>
+      </p:sp>
+      <p:sp>
+        <p:nvSpPr>
+          <p:cNvPr id="4" name="Slide Number Placeholder 3">
+            <a:extLst>
+              <a:ext uri="{FF2B5EF4-FFF2-40B4-BE49-F238E27FC236}">
+                <a16:creationId xmlns:a16="http://schemas.microsoft.com/office/drawing/2014/main" id="{ED338F9C-5E35-D00E-AD28-C7865A5DEFCD}"/>
+              </a:ext>
+            </a:extLst>
+          </p:cNvPr>
+          <p:cNvSpPr>
+            <a:spLocks noGrp="1"/>
+          </p:cNvSpPr>
+          <p:nvPr>
+            <p:ph type="sldNum" sz="quarter" idx="4"/>
+          </p:nvPr>
+        </p:nvSpPr>
+        <p:spPr/>
+        <p:txBody>
+          <a:bodyPr/>
+          <a:lstStyle/>
+          <a:p>
+            <a:fld id="{B5CEABB6-07DC-46E8-9B57-56EC44A396E5}" type="slidenum">
+              <a:rPr lang="en-US" smtClean="0"/>
+              <a:pPr/>
+              <a:t>11</a:t>
+            </a:fld>
+            <a:endParaRPr lang="en-US" dirty="0"/>
+          </a:p>
+        </p:txBody>
+      </p:sp>
+      <p:sp>
+        <p:nvSpPr>
+          <p:cNvPr id="5" name="Inhaltsplatzhalter 4">
+            <a:extLst>
+              <a:ext uri="{FF2B5EF4-FFF2-40B4-BE49-F238E27FC236}">
+                <a16:creationId xmlns:a16="http://schemas.microsoft.com/office/drawing/2014/main" id="{AABF827B-9DE4-A20E-4C3C-0EB8175F3CEF}"/>
+              </a:ext>
+            </a:extLst>
+          </p:cNvPr>
+          <p:cNvSpPr>
+            <a:spLocks noGrp="1"/>
+          </p:cNvSpPr>
+          <p:nvPr>
+            <p:ph sz="quarter" idx="10"/>
+          </p:nvPr>
+        </p:nvSpPr>
+        <p:spPr>
+          <a:xfrm>
+            <a:off x="914399" y="2011363"/>
+            <a:ext cx="9676054" cy="4155757"/>
+          </a:xfrm>
+        </p:spPr>
+        <p:txBody>
+          <a:bodyPr vert="horz" lIns="91440" tIns="45720" rIns="91440" bIns="45720" rtlCol="0" anchor="t">
+            <a:normAutofit/>
+          </a:bodyPr>
+          <a:lstStyle/>
+          <a:p>
+            <a:r>
+              <a:rPr lang="de-DE" dirty="0" err="1"/>
+              <a:t>OpenAQ</a:t>
+            </a:r>
+            <a:r>
+              <a:rPr lang="de-DE" dirty="0"/>
+              <a:t> API</a:t>
+            </a:r>
+          </a:p>
+          <a:p>
+            <a:r>
+              <a:rPr lang="de-DE" dirty="0"/>
+              <a:t>e.g. Germany vs. France -&gt; </a:t>
+            </a:r>
+            <a:r>
+              <a:rPr lang="de-DE" dirty="0" err="1"/>
+              <a:t>compare</a:t>
+            </a:r>
+            <a:r>
+              <a:rPr lang="de-DE" dirty="0"/>
+              <a:t> </a:t>
+            </a:r>
+            <a:r>
+              <a:rPr lang="de-DE" dirty="0" err="1"/>
+              <a:t>daily</a:t>
+            </a:r>
+            <a:r>
+              <a:rPr lang="de-DE" dirty="0"/>
+              <a:t> </a:t>
+            </a:r>
+            <a:r>
+              <a:rPr lang="de-DE" dirty="0" err="1"/>
+              <a:t>average</a:t>
+            </a:r>
+            <a:r>
+              <a:rPr lang="de-DE" dirty="0"/>
+              <a:t> </a:t>
+            </a:r>
+            <a:r>
+              <a:rPr lang="de-DE" dirty="0" err="1"/>
+              <a:t>concentrations</a:t>
+            </a:r>
+            <a:r>
+              <a:rPr lang="de-DE" dirty="0"/>
+              <a:t> </a:t>
+            </a:r>
+            <a:r>
+              <a:rPr lang="de-DE" dirty="0" err="1"/>
+              <a:t>of</a:t>
+            </a:r>
+            <a:r>
+              <a:rPr lang="de-DE" dirty="0"/>
+              <a:t> PM2.5, PM10 and NO2 </a:t>
+            </a:r>
+            <a:endParaRPr lang="de-DE" baseline="-25000" dirty="0"/>
+          </a:p>
+        </p:txBody>
+      </p:sp>
+      <p:pic>
+        <p:nvPicPr>
+          <p:cNvPr id="7" name="Grafik 6" descr="Ein Bild, das Text, Schrift, Screenshot, Zahl enthält.&#10;&#10;KI-generierte Inhalte können fehlerhaft sein.">
+            <a:extLst>
+              <a:ext uri="{FF2B5EF4-FFF2-40B4-BE49-F238E27FC236}">
+                <a16:creationId xmlns:a16="http://schemas.microsoft.com/office/drawing/2014/main" id="{D4B13910-36BA-7299-66FD-9969D6C671C4}"/>
+              </a:ext>
+            </a:extLst>
+          </p:cNvPr>
+          <p:cNvPicPr>
+            <a:picLocks noChangeAspect="1"/>
+          </p:cNvPicPr>
+          <p:nvPr/>
+        </p:nvPicPr>
+        <p:blipFill>
+          <a:blip r:embed="rId4"/>
+          <a:stretch>
+            <a:fillRect/>
+          </a:stretch>
+        </p:blipFill>
+        <p:spPr>
+          <a:xfrm>
+            <a:off x="1300691" y="3340099"/>
+            <a:ext cx="1970617" cy="897467"/>
+          </a:xfrm>
+          <a:prstGeom prst="rect">
+            <a:avLst/>
+          </a:prstGeom>
+        </p:spPr>
+      </p:pic>
+      <p:pic>
+        <p:nvPicPr>
+          <p:cNvPr id="8" name="Grafik 7" descr="Ein Bild, das Text, Schrift, Screenshot, Design enthält.&#10;&#10;KI-generierte Inhalte können fehlerhaft sein.">
+            <a:extLst>
+              <a:ext uri="{FF2B5EF4-FFF2-40B4-BE49-F238E27FC236}">
+                <a16:creationId xmlns:a16="http://schemas.microsoft.com/office/drawing/2014/main" id="{2DEB00A4-F9C3-E9A6-2293-F993F35F5E48}"/>
+              </a:ext>
+            </a:extLst>
+          </p:cNvPr>
+          <p:cNvPicPr>
+            <a:picLocks noChangeAspect="1"/>
+          </p:cNvPicPr>
+          <p:nvPr/>
+        </p:nvPicPr>
+        <p:blipFill>
+          <a:blip r:embed="rId5"/>
+          <a:stretch>
+            <a:fillRect/>
+          </a:stretch>
+        </p:blipFill>
+        <p:spPr>
+          <a:xfrm>
+            <a:off x="1081088" y="4568824"/>
+            <a:ext cx="2409825" cy="1466850"/>
+          </a:xfrm>
+          <a:prstGeom prst="rect">
+            <a:avLst/>
+          </a:prstGeom>
+        </p:spPr>
+      </p:pic>
+      <p:pic>
+        <p:nvPicPr>
+          <p:cNvPr id="11" name="Grafik 10" descr="Ein Bild, das Text, Schrift, Screenshot, Typografie enthält.&#10;&#10;KI-generierte Inhalte können fehlerhaft sein.">
+            <a:extLst>
+              <a:ext uri="{FF2B5EF4-FFF2-40B4-BE49-F238E27FC236}">
+                <a16:creationId xmlns:a16="http://schemas.microsoft.com/office/drawing/2014/main" id="{4AB8BEC9-CCE2-E29D-37E8-31393F3ED072}"/>
+              </a:ext>
+            </a:extLst>
+          </p:cNvPr>
+          <p:cNvPicPr>
+            <a:picLocks noChangeAspect="1"/>
+          </p:cNvPicPr>
+          <p:nvPr/>
+        </p:nvPicPr>
+        <p:blipFill>
+          <a:blip r:embed="rId6"/>
+          <a:stretch>
+            <a:fillRect/>
+          </a:stretch>
+        </p:blipFill>
+        <p:spPr>
+          <a:xfrm>
+            <a:off x="5235575" y="3567113"/>
+            <a:ext cx="2228850" cy="2009775"/>
+          </a:xfrm>
+          <a:prstGeom prst="rect">
+            <a:avLst/>
+          </a:prstGeom>
+        </p:spPr>
+      </p:pic>
+    </p:spTree>
+    <p:extLst>
+      <p:ext uri="{BB962C8B-B14F-4D97-AF65-F5344CB8AC3E}">
+        <p14:creationId xmlns:p14="http://schemas.microsoft.com/office/powerpoint/2010/main" val="4212598987"/>
+      </p:ext>
+    </p:extLst>
+  </p:cSld>
+  <p:clrMapOvr>
+    <a:masterClrMapping/>
+  </p:clrMapOvr>
+</p:sld>
+</file>
+
+<file path=ppt/slides/slide12.xml><?xml version="1.0" encoding="utf-8"?>
+<p:sld xmlns:a="http://schemas.openxmlformats.org/drawingml/2006/main" xmlns:r="http://schemas.openxmlformats.org/officeDocument/2006/relationships" xmlns:p="http://schemas.openxmlformats.org/presentationml/2006/main">
+  <p:cSld>
+    <p:spTree>
+      <p:nvGrpSpPr>
+        <p:cNvPr id="1" name="">
+          <a:extLst>
+            <a:ext uri="{FF2B5EF4-FFF2-40B4-BE49-F238E27FC236}">
+              <a16:creationId xmlns:a16="http://schemas.microsoft.com/office/drawing/2014/main" id="{24E0BB17-AE89-2A2E-46D9-411A2BA65C3E}"/>
+            </a:ext>
+          </a:extLst>
+        </p:cNvPr>
+        <p:cNvGrpSpPr/>
+        <p:nvPr/>
+      </p:nvGrpSpPr>
+      <p:grpSpPr>
+        <a:xfrm>
+          <a:off x="0" y="0"/>
+          <a:ext cx="0" cy="0"/>
+          <a:chOff x="0" y="0"/>
+          <a:chExt cx="0" cy="0"/>
+        </a:xfrm>
+      </p:grpSpPr>
+      <p:sp>
+        <p:nvSpPr>
+          <p:cNvPr id="2" name="Title 1">
+            <a:extLst>
+              <a:ext uri="{FF2B5EF4-FFF2-40B4-BE49-F238E27FC236}">
+                <a16:creationId xmlns:a16="http://schemas.microsoft.com/office/drawing/2014/main" id="{C92C41A8-4A1A-0C10-9C2D-192ECF84010B}"/>
+              </a:ext>
+            </a:extLst>
+          </p:cNvPr>
+          <p:cNvSpPr>
+            <a:spLocks noGrp="1"/>
+          </p:cNvSpPr>
+          <p:nvPr>
+            <p:ph type="title"/>
+          </p:nvPr>
+        </p:nvSpPr>
+        <p:spPr>
+          <a:xfrm>
+            <a:off x="914399" y="365125"/>
+            <a:ext cx="10505662" cy="1646555"/>
+          </a:xfrm>
+        </p:spPr>
+        <p:txBody>
+          <a:bodyPr/>
+          <a:lstStyle/>
+          <a:p>
+            <a:r>
+              <a:rPr lang="en-US" dirty="0"/>
+              <a:t>Air Pollution</a:t>
+            </a:r>
+            <a:r>
+              <a:rPr lang="en-US" sz="3200" dirty="0"/>
+              <a:t> – </a:t>
+            </a:r>
+            <a:r>
+              <a:rPr lang="de-DE" dirty="0" err="1"/>
+              <a:t>Upcoming</a:t>
+            </a:r>
+            <a:r>
+              <a:rPr lang="de-DE" dirty="0"/>
+              <a:t> </a:t>
+            </a:r>
+            <a:r>
+              <a:rPr lang="de-DE" dirty="0" err="1"/>
+              <a:t>steps</a:t>
+            </a:r>
+            <a:endParaRPr lang="en-US" sz="3200" dirty="0"/>
+          </a:p>
+        </p:txBody>
+      </p:sp>
+      <p:sp>
+        <p:nvSpPr>
+          <p:cNvPr id="4" name="Slide Number Placeholder 3">
+            <a:extLst>
+              <a:ext uri="{FF2B5EF4-FFF2-40B4-BE49-F238E27FC236}">
+                <a16:creationId xmlns:a16="http://schemas.microsoft.com/office/drawing/2014/main" id="{E901DA36-2467-0552-0B99-86A75E0E86AA}"/>
+              </a:ext>
+            </a:extLst>
+          </p:cNvPr>
+          <p:cNvSpPr>
+            <a:spLocks noGrp="1"/>
+          </p:cNvSpPr>
+          <p:nvPr>
+            <p:ph type="sldNum" sz="quarter" idx="4"/>
+          </p:nvPr>
+        </p:nvSpPr>
+        <p:spPr/>
+        <p:txBody>
+          <a:bodyPr/>
+          <a:lstStyle/>
+          <a:p>
+            <a:fld id="{B5CEABB6-07DC-46E8-9B57-56EC44A396E5}" type="slidenum">
+              <a:rPr lang="en-US" smtClean="0"/>
+              <a:pPr/>
+              <a:t>12</a:t>
+            </a:fld>
+            <a:endParaRPr lang="en-US" dirty="0"/>
+          </a:p>
+        </p:txBody>
+      </p:sp>
+      <p:sp>
+        <p:nvSpPr>
+          <p:cNvPr id="5" name="Inhaltsplatzhalter 4">
+            <a:extLst>
+              <a:ext uri="{FF2B5EF4-FFF2-40B4-BE49-F238E27FC236}">
+                <a16:creationId xmlns:a16="http://schemas.microsoft.com/office/drawing/2014/main" id="{1A8A3AFF-2E88-A66B-4792-10592C91D603}"/>
+              </a:ext>
+            </a:extLst>
+          </p:cNvPr>
+          <p:cNvSpPr>
+            <a:spLocks noGrp="1"/>
+          </p:cNvSpPr>
+          <p:nvPr>
+            <p:ph sz="quarter" idx="10"/>
+          </p:nvPr>
+        </p:nvSpPr>
+        <p:spPr/>
+        <p:txBody>
+          <a:bodyPr/>
+          <a:lstStyle/>
+          <a:p>
+            <a:r>
+              <a:rPr lang="en-US" dirty="0"/>
+              <a:t>CSV files with the relevant data for research questions 1 to 5 are already complete </a:t>
+            </a:r>
+            <a:br>
+              <a:rPr lang="en-US" dirty="0"/>
+            </a:br>
+            <a:endParaRPr lang="en-US" dirty="0"/>
+          </a:p>
+          <a:p>
+            <a:r>
+              <a:rPr lang="en-US" dirty="0"/>
+              <a:t>CSV files for questions 6 to 8 are also partially complete, and the rest should be available by the end of the week at the latest</a:t>
+            </a:r>
+            <a:br>
+              <a:rPr lang="en-US" dirty="0"/>
+            </a:br>
+            <a:endParaRPr lang="en-US" dirty="0"/>
+          </a:p>
+          <a:p>
+            <a:r>
+              <a:rPr lang="en-US" dirty="0"/>
+              <a:t>Once everything is available, we can start working on presenting the CSV data in the form of graphics for better visualization. However, we first need to look at how to implement the dynamic display</a:t>
+            </a:r>
+          </a:p>
+          <a:p>
+            <a:endParaRPr lang="en-US" dirty="0"/>
+          </a:p>
+          <a:p>
+            <a:endParaRPr lang="de-DE" dirty="0"/>
+          </a:p>
+        </p:txBody>
+      </p:sp>
+    </p:spTree>
+    <p:extLst>
+      <p:ext uri="{BB962C8B-B14F-4D97-AF65-F5344CB8AC3E}">
+        <p14:creationId xmlns:p14="http://schemas.microsoft.com/office/powerpoint/2010/main" val="836621703"/>
+      </p:ext>
+    </p:extLst>
+  </p:cSld>
+  <p:clrMapOvr>
+    <a:masterClrMapping/>
+  </p:clrMapOvr>
+</p:sld>
+</file>
+
+<file path=ppt/slides/slide13.xml><?xml version="1.0" encoding="utf-8"?>
+<p:sld xmlns:a="http://schemas.openxmlformats.org/drawingml/2006/main" xmlns:r="http://schemas.openxmlformats.org/officeDocument/2006/relationships" xmlns:p="http://schemas.openxmlformats.org/presentationml/2006/main">
+  <p:cSld>
+    <p:spTree>
+      <p:nvGrpSpPr>
+        <p:cNvPr id="1" name="">
+          <a:extLst>
+            <a:ext uri="{FF2B5EF4-FFF2-40B4-BE49-F238E27FC236}">
+              <a16:creationId xmlns:a16="http://schemas.microsoft.com/office/drawing/2014/main" id="{B17F2D26-E0CC-D3F8-2F90-2DD9D260CBB4}"/>
+            </a:ext>
+          </a:extLst>
+        </p:cNvPr>
+        <p:cNvGrpSpPr/>
+        <p:nvPr/>
+      </p:nvGrpSpPr>
+      <p:grpSpPr>
+        <a:xfrm>
+          <a:off x="0" y="0"/>
+          <a:ext cx="0" cy="0"/>
+          <a:chOff x="0" y="0"/>
+          <a:chExt cx="0" cy="0"/>
+        </a:xfrm>
+      </p:grpSpPr>
+      <p:sp>
+        <p:nvSpPr>
+          <p:cNvPr id="2" name="Title 1">
+            <a:extLst>
+              <a:ext uri="{FF2B5EF4-FFF2-40B4-BE49-F238E27FC236}">
+                <a16:creationId xmlns:a16="http://schemas.microsoft.com/office/drawing/2014/main" id="{F14F2DDA-6ABA-4FCD-2F59-91B0253CA16B}"/>
+              </a:ext>
+            </a:extLst>
+          </p:cNvPr>
+          <p:cNvSpPr>
+            <a:spLocks noGrp="1"/>
+          </p:cNvSpPr>
+          <p:nvPr>
+            <p:ph type="title"/>
+          </p:nvPr>
+        </p:nvSpPr>
+        <p:spPr>
+          <a:xfrm>
+            <a:off x="914399" y="365125"/>
+            <a:ext cx="8458201" cy="1646555"/>
+          </a:xfrm>
+        </p:spPr>
+        <p:txBody>
+          <a:bodyPr/>
+          <a:lstStyle/>
+          <a:p>
+            <a:r>
+              <a:rPr lang="en-US" dirty="0"/>
+              <a:t>Air Pollution</a:t>
+            </a:r>
+            <a:r>
+              <a:rPr lang="en-US" sz="3200" dirty="0"/>
+              <a:t> – Challenges</a:t>
+            </a:r>
+          </a:p>
+        </p:txBody>
+      </p:sp>
+      <p:sp>
+        <p:nvSpPr>
+          <p:cNvPr id="4" name="Slide Number Placeholder 3">
+            <a:extLst>
+              <a:ext uri="{FF2B5EF4-FFF2-40B4-BE49-F238E27FC236}">
+                <a16:creationId xmlns:a16="http://schemas.microsoft.com/office/drawing/2014/main" id="{D13B2B89-1D29-99F9-1482-6A9FA7915706}"/>
+              </a:ext>
+            </a:extLst>
+          </p:cNvPr>
+          <p:cNvSpPr>
+            <a:spLocks noGrp="1"/>
+          </p:cNvSpPr>
+          <p:nvPr>
+            <p:ph type="sldNum" sz="quarter" idx="4"/>
+          </p:nvPr>
+        </p:nvSpPr>
+        <p:spPr/>
+        <p:txBody>
+          <a:bodyPr/>
+          <a:lstStyle/>
+          <a:p>
+            <a:fld id="{B5CEABB6-07DC-46E8-9B57-56EC44A396E5}" type="slidenum">
+              <a:rPr lang="en-US" smtClean="0"/>
+              <a:pPr/>
+              <a:t>13</a:t>
+            </a:fld>
+            <a:endParaRPr lang="en-US" dirty="0"/>
+          </a:p>
+        </p:txBody>
+      </p:sp>
+      <p:sp>
+        <p:nvSpPr>
+          <p:cNvPr id="6" name="Content Placeholder 5">
+            <a:extLst>
+              <a:ext uri="{FF2B5EF4-FFF2-40B4-BE49-F238E27FC236}">
+                <a16:creationId xmlns:a16="http://schemas.microsoft.com/office/drawing/2014/main" id="{A3698340-C24A-E811-4C27-2815D6736E7B}"/>
+              </a:ext>
+            </a:extLst>
+          </p:cNvPr>
+          <p:cNvSpPr>
+            <a:spLocks noGrp="1"/>
+          </p:cNvSpPr>
+          <p:nvPr>
+            <p:ph sz="quarter" idx="10"/>
+          </p:nvPr>
+        </p:nvSpPr>
+        <p:spPr>
+          <a:xfrm>
+            <a:off x="914398" y="2011363"/>
+            <a:ext cx="7849457" cy="4155757"/>
+          </a:xfrm>
+        </p:spPr>
+        <p:txBody>
+          <a:bodyPr>
+            <a:normAutofit/>
+          </a:bodyPr>
+          <a:lstStyle/>
+          <a:p>
+            <a:pPr marL="0" lvl="0" indent="0">
+              <a:buNone/>
+            </a:pPr>
+            <a:r>
+              <a:rPr lang="de-DE" dirty="0"/>
+              <a:t>• </a:t>
+            </a:r>
+            <a:r>
+              <a:rPr lang="en-US" dirty="0"/>
+              <a:t>with some APIs, you can only make a limited number of requests</a:t>
+            </a:r>
+            <a:endParaRPr lang="en-DE" sz="1600" dirty="0"/>
+          </a:p>
+        </p:txBody>
+      </p:sp>
+    </p:spTree>
+    <p:extLst>
+      <p:ext uri="{BB962C8B-B14F-4D97-AF65-F5344CB8AC3E}">
+        <p14:creationId xmlns:p14="http://schemas.microsoft.com/office/powerpoint/2010/main" val="2307799448"/>
+      </p:ext>
+    </p:extLst>
+  </p:cSld>
+  <p:clrMapOvr>
+    <a:masterClrMapping/>
+  </p:clrMapOvr>
+</p:sld>
+</file>
+
+<file path=ppt/slides/slide14.xml><?xml version="1.0" encoding="utf-8"?>
+<p:sld xmlns:a="http://schemas.openxmlformats.org/drawingml/2006/main" xmlns:r="http://schemas.openxmlformats.org/officeDocument/2006/relationships" xmlns:p="http://schemas.openxmlformats.org/presentationml/2006/main">
+  <p:cSld>
     <p:bg>
       <p:bgPr>
         <a:solidFill>
@@ -7158,7 +7984,57 @@
             </a:pPr>
             <a:r>
               <a:rPr lang="de-DE" dirty="0"/>
-              <a:t>Questions</a:t>
+              <a:t>Research Questions</a:t>
+            </a:r>
+          </a:p>
+          <a:p>
+            <a:pPr marL="342900" indent="-342900">
+              <a:buFontTx/>
+              <a:buChar char="-"/>
+            </a:pPr>
+            <a:r>
+              <a:rPr lang="de-DE" dirty="0"/>
+              <a:t>APIs</a:t>
+            </a:r>
+          </a:p>
+          <a:p>
+            <a:pPr marL="342900" indent="-342900">
+              <a:buFontTx/>
+              <a:buChar char="-"/>
+            </a:pPr>
+            <a:r>
+              <a:rPr lang="de-DE" dirty="0" err="1"/>
+              <a:t>Achivements</a:t>
+            </a:r>
+            <a:endParaRPr lang="de-DE" dirty="0"/>
+          </a:p>
+          <a:p>
+            <a:pPr marL="342900" indent="-342900">
+              <a:buFontTx/>
+              <a:buChar char="-"/>
+            </a:pPr>
+            <a:r>
+              <a:rPr lang="de-DE" dirty="0" err="1"/>
+              <a:t>Upcoming</a:t>
+            </a:r>
+            <a:r>
+              <a:rPr lang="de-DE" dirty="0"/>
+              <a:t> </a:t>
+            </a:r>
+            <a:r>
+              <a:rPr lang="de-DE" dirty="0" err="1"/>
+              <a:t>steps</a:t>
+            </a:r>
+            <a:endParaRPr lang="de-DE" dirty="0"/>
+          </a:p>
+          <a:p>
+            <a:pPr marL="342900" indent="-342900">
+              <a:buFontTx/>
+              <a:buChar char="-"/>
+            </a:pPr>
+            <a:r>
+              <a:rPr lang="de-DE" dirty="0"/>
+              <a:t>Challenges</a:t>
             </a:r>
             <a:endParaRPr lang="en-DE" dirty="0"/>
           </a:p>
@@ -7327,14 +8203,19 @@
             <p:ph type="title"/>
           </p:nvPr>
         </p:nvSpPr>
-        <p:spPr/>
+        <p:spPr>
+          <a:xfrm>
+            <a:off x="914399" y="365125"/>
+            <a:ext cx="9041259" cy="1646555"/>
+          </a:xfrm>
+        </p:spPr>
         <p:txBody>
           <a:bodyPr/>
           <a:lstStyle/>
           <a:p>
             <a:r>
               <a:rPr lang="en-US" dirty="0"/>
-              <a:t>Air Pollution – New Questions</a:t>
+              <a:t>Air Pollution – research Questions</a:t>
             </a:r>
             <a:r>
               <a:rPr lang="en-US" sz="3200" dirty="0"/>
@@ -7408,8 +8289,16 @@
               <a:buNone/>
             </a:pPr>
             <a:r>
-              <a:rPr lang="en-GB" sz="1600" b="1" dirty="0"/>
-              <a:t>1. How have the annual mean concentrations of PM10, PM2, and NO₂ in Germany developed over the period 2000–2025? </a:t>
+              <a:rPr lang="en-US" sz="1600" b="1" u="sng" dirty="0"/>
+              <a:t>1.</a:t>
+            </a:r>
+            <a:r>
+              <a:rPr lang="en-US" sz="1600" b="1" dirty="0"/>
+              <a:t> </a:t>
+            </a:r>
+            <a:r>
+              <a:rPr lang="en-US" sz="1600" dirty="0"/>
+              <a:t>How do the average yearly values of PM10, PM2.5 and NO₂ change in Germany from 2016-2026?</a:t>
             </a:r>
           </a:p>
           <a:p>
@@ -7420,8 +8309,12 @@
               <a:buNone/>
             </a:pPr>
             <a:r>
-              <a:rPr lang="en-GB" sz="1600" b="1" dirty="0"/>
-              <a:t>2. Were there significant changes in NO₂ and PM10 concentrations during the COVID-19-related mobility restrictions compared to the same periods in previous years?</a:t>
+              <a:rPr lang="en-US" sz="1600" b="1" u="sng" dirty="0"/>
+              <a:t>2.1</a:t>
+            </a:r>
+            <a:r>
+              <a:rPr lang="en-US" sz="1600" dirty="0"/>
+              <a:t> How did New Years Eve change the air pollution from 2016 to 2025?</a:t>
             </a:r>
           </a:p>
           <a:p>
@@ -7432,8 +8325,12 @@
               <a:buNone/>
             </a:pPr>
             <a:r>
-              <a:rPr lang="en-GB" sz="1600" b="1" dirty="0"/>
-              <a:t>3. Do the daily mean values of PM10 and PM2 on New Years differ significantly between the years 2000–2025?</a:t>
+              <a:rPr lang="en-US" sz="1600" b="1" u="sng" dirty="0"/>
+              <a:t>2.2</a:t>
+            </a:r>
+            <a:r>
+              <a:rPr lang="en-US" sz="1600" dirty="0"/>
+              <a:t> How did the COVID-19 pandemic affect the air pollution compared to the previous and following years?</a:t>
             </a:r>
           </a:p>
           <a:p>
@@ -7444,8 +8341,12 @@
               <a:buNone/>
             </a:pPr>
             <a:r>
-              <a:rPr lang="en-GB" sz="1600" dirty="0"/>
-              <a:t>4. Are there significant differences in the annual mean PM2 concentrations between the German federal states over the past 25 years?</a:t>
+              <a:rPr lang="en-US" sz="1600" b="1" u="sng" dirty="0"/>
+              <a:t>3</a:t>
+            </a:r>
+            <a:r>
+              <a:rPr lang="en-US" sz="1600" dirty="0"/>
+              <a:t> How much do the annual average values for PM10, PM2.5, and NO_2 differ between the federal states in the period 2016–2026?</a:t>
             </a:r>
           </a:p>
           <a:p>
@@ -7456,9 +8357,54 @@
               <a:buNone/>
             </a:pPr>
             <a:r>
-              <a:rPr lang="en-GB" sz="1600" dirty="0"/>
-              <a:t>5. Do PM10 concentrations differ significantly between urban, suburban, and rural monitoring stations?</a:t>
-            </a:r>
+              <a:rPr lang="en-US" sz="1600" b="1" u="sng" dirty="0">
+                <a:highlight>
+                  <a:srgbClr val="FFFF00"/>
+                </a:highlight>
+              </a:rPr>
+              <a:t>4.1</a:t>
+            </a:r>
+            <a:r>
+              <a:rPr lang="en-US" sz="1600" dirty="0">
+                <a:highlight>
+                  <a:srgbClr val="FFFF00"/>
+                </a:highlight>
+              </a:rPr>
+              <a:t> How do the PM10 concentration between urban, suburban and rural areas differ in the period 2016-2026?</a:t>
+            </a:r>
+          </a:p>
+          <a:p>
+            <a:pPr marL="0" indent="0">
+              <a:lnSpc>
+                <a:spcPct val="100000"/>
+              </a:lnSpc>
+              <a:buNone/>
+            </a:pPr>
+            <a:r>
+              <a:rPr lang="en-US" sz="1600" b="1" u="sng" dirty="0">
+                <a:highlight>
+                  <a:srgbClr val="FFFF00"/>
+                </a:highlight>
+              </a:rPr>
+              <a:t>4.2</a:t>
+            </a:r>
+            <a:r>
+              <a:rPr lang="en-US" sz="1600" dirty="0">
+                <a:highlight>
+                  <a:srgbClr val="FFFF00"/>
+                </a:highlight>
+              </a:rPr>
+              <a:t> Do the data for urban, suburban, and rural measuring stations differ in terms of the positioning of the stations (background, traffic, industry) in the period 2016-2026?</a:t>
+            </a:r>
+          </a:p>
+          <a:p>
+            <a:pPr marL="0" indent="0">
+              <a:lnSpc>
+                <a:spcPct val="100000"/>
+              </a:lnSpc>
+              <a:buNone/>
+            </a:pPr>
+            <a:endParaRPr lang="en-US" sz="1600" dirty="0"/>
           </a:p>
         </p:txBody>
       </p:sp>
@@ -7514,14 +8460,19 @@
             <p:ph type="title"/>
           </p:nvPr>
         </p:nvSpPr>
-        <p:spPr/>
+        <p:spPr>
+          <a:xfrm>
+            <a:off x="914399" y="365125"/>
+            <a:ext cx="8753583" cy="1646555"/>
+          </a:xfrm>
+        </p:spPr>
         <p:txBody>
           <a:bodyPr/>
           <a:lstStyle/>
           <a:p>
             <a:r>
               <a:rPr lang="en-US" sz="3200" dirty="0"/>
-              <a:t>Air Pollution - </a:t>
+              <a:t>Air Pollution – Research </a:t>
             </a:r>
             <a:r>
               <a:rPr lang="en-US" sz="3200" dirty="0" err="1"/>
@@ -7582,7 +8533,7 @@
         </p:nvSpPr>
         <p:spPr/>
         <p:txBody>
-          <a:bodyPr>
+          <a:bodyPr vert="horz" lIns="91440" tIns="45720" rIns="91440" bIns="45720" rtlCol="0" anchor="t">
             <a:noAutofit/>
           </a:bodyPr>
           <a:lstStyle/>
@@ -7591,8 +8542,12 @@
               <a:buNone/>
             </a:pPr>
             <a:r>
-              <a:rPr lang="en-GB" sz="1600" dirty="0"/>
-              <a:t>6. How do the annual mean PM2 concentrations in Germany compare to those in comparable EU countries over the period 2000–2025?</a:t>
+              <a:rPr lang="en-US" sz="1600" b="1" u="sng" dirty="0"/>
+              <a:t>5</a:t>
+            </a:r>
+            <a:r>
+              <a:rPr lang="en-US" sz="1600" dirty="0"/>
+              <a:t> How do the PM10 concentrations vary between seasons in the years 2016 to 2026?</a:t>
             </a:r>
           </a:p>
           <a:p>
@@ -7600,18 +8555,41 @@
               <a:buNone/>
             </a:pPr>
             <a:r>
-              <a:rPr lang="en-GB" sz="1600" dirty="0"/>
-              <a:t>7. How strongly do PM10 concentrations vary between the seasons?</a:t>
-            </a:r>
-            <a:endParaRPr lang="en-GB" sz="1600" b="1" dirty="0"/>
+              <a:rPr lang="en-US" sz="1600" b="1" u="sng">
+                <a:highlight>
+                  <a:srgbClr val="FFFF00"/>
+                </a:highlight>
+              </a:rPr>
+              <a:t>6.1</a:t>
+            </a:r>
+            <a:r>
+              <a:rPr lang="en-US" sz="1600" dirty="0">
+                <a:highlight>
+                  <a:srgbClr val="FFFF00"/>
+                </a:highlight>
+              </a:rPr>
+              <a:t> How does daily maximum temperature influence PM10 and PM2.5 concentrations in major German cities between 2016 and 2026?</a:t>
+            </a:r>
           </a:p>
           <a:p>
             <a:pPr marL="0" indent="0">
               <a:buNone/>
             </a:pPr>
             <a:r>
-              <a:rPr lang="en-GB" sz="1600" b="1" dirty="0"/>
-              <a:t>8. Is there a significant positive correlation between O₃ concentrations and daily maximum temperatures in the German federal states?</a:t>
+              <a:rPr lang="en-US" sz="1600" b="1" u="sng">
+                <a:highlight>
+                  <a:srgbClr val="FFFF00"/>
+                </a:highlight>
+              </a:rPr>
+              <a:t>6.2</a:t>
+            </a:r>
+            <a:r>
+              <a:rPr lang="en-US" sz="1600" dirty="0">
+                <a:highlight>
+                  <a:srgbClr val="FFFF00"/>
+                </a:highlight>
+              </a:rPr>
+              <a:t> How do rainfall patterns relate to changes in PM10 and PM2.5 concentrations in major German cities between 2016 and 2026?</a:t>
             </a:r>
           </a:p>
           <a:p>
@@ -7619,9 +8597,73 @@
               <a:buNone/>
             </a:pPr>
             <a:r>
-              <a:rPr lang="en-GB" sz="1600" dirty="0"/>
-              <a:t>9. Is there a relationship between seasonal tourism intensity and short-term changes in NO₂ or PM10 concentrations in tourist regions?</a:t>
-            </a:r>
+              <a:rPr lang="en-US" sz="1600" b="1" u="sng">
+                <a:highlight>
+                  <a:srgbClr val="FFFF00"/>
+                </a:highlight>
+              </a:rPr>
+              <a:t>7</a:t>
+            </a:r>
+            <a:r>
+              <a:rPr lang="en-US" sz="1600" dirty="0">
+                <a:highlight>
+                  <a:srgbClr val="FFFF00"/>
+                </a:highlight>
+              </a:rPr>
+              <a:t> What is the impact of summer school holidays in the individual federal states on NO_2 concentrations in the years 2016 to 2026?</a:t>
+            </a:r>
+          </a:p>
+          <a:p>
+            <a:pPr marL="0" indent="0">
+              <a:buNone/>
+            </a:pPr>
+            <a:r>
+              <a:rPr lang="en-US" sz="1600" b="1" u="sng" dirty="0">
+                <a:highlight>
+                  <a:srgbClr val="FFFF00"/>
+                </a:highlight>
+              </a:rPr>
+              <a:t>8</a:t>
+            </a:r>
+            <a:r>
+              <a:rPr lang="en-US" sz="1600" dirty="0">
+                <a:highlight>
+                  <a:srgbClr val="FFFF00"/>
+                </a:highlight>
+              </a:rPr>
+              <a:t> </a:t>
+            </a:r>
+            <a:r>
+              <a:rPr lang="en-US" sz="1600">
+                <a:highlight>
+                  <a:srgbClr val="FFFF00"/>
+                </a:highlight>
+                <a:ea typeface="+mn-lt"/>
+                <a:cs typeface="+mn-lt"/>
+              </a:rPr>
+              <a:t>How does Germany compare to other countries in terms of the daily</a:t>
+            </a:r>
+            <a:r>
+              <a:rPr lang="en-US" sz="1600">
+                <a:highlight>
+                  <a:srgbClr val="FFFF00"/>
+                </a:highlight>
+              </a:rPr>
+              <a:t> average concentrations of PM2.5, PM10 and NO2</a:t>
+            </a:r>
+            <a:r>
+              <a:rPr lang="en-US" sz="1600" dirty="0">
+                <a:highlight>
+                  <a:srgbClr val="FFFF00"/>
+                </a:highlight>
+              </a:rPr>
+              <a:t>?</a:t>
+            </a:r>
+            <a:endParaRPr lang="en-GB" sz="1600" dirty="0">
+              <a:highlight>
+                <a:srgbClr val="FFFF00"/>
+              </a:highlight>
+            </a:endParaRPr>
           </a:p>
         </p:txBody>
       </p:sp>
@@ -7688,7 +8730,15 @@
             </a:r>
             <a:r>
               <a:rPr lang="en-US" sz="3200" dirty="0"/>
-              <a:t> – our Apis </a:t>
+              <a:t> – our Api</a:t>
+            </a:r>
+            <a:r>
+              <a:rPr lang="en-US" sz="2000" b="1" dirty="0"/>
+              <a:t>s</a:t>
+            </a:r>
+            <a:r>
+              <a:rPr lang="en-US" sz="3200" dirty="0"/>
+              <a:t> </a:t>
             </a:r>
           </a:p>
         </p:txBody>
@@ -7835,6 +8885,299 @@
 </file>
 
 <file path=ppt/slides/slide7.xml><?xml version="1.0" encoding="utf-8"?>
+<p:sld xmlns:a="http://schemas.openxmlformats.org/drawingml/2006/main" xmlns:r="http://schemas.openxmlformats.org/officeDocument/2006/relationships" xmlns:p="http://schemas.openxmlformats.org/presentationml/2006/main">
+  <p:cSld>
+    <p:spTree>
+      <p:nvGrpSpPr>
+        <p:cNvPr id="1" name="">
+          <a:extLst>
+            <a:ext uri="{FF2B5EF4-FFF2-40B4-BE49-F238E27FC236}">
+              <a16:creationId xmlns:a16="http://schemas.microsoft.com/office/drawing/2014/main" id="{F0CFD671-F6BE-D528-71FC-054F0200B6E1}"/>
+            </a:ext>
+          </a:extLst>
+        </p:cNvPr>
+        <p:cNvGrpSpPr/>
+        <p:nvPr/>
+      </p:nvGrpSpPr>
+      <p:grpSpPr>
+        <a:xfrm>
+          <a:off x="0" y="0"/>
+          <a:ext cx="0" cy="0"/>
+          <a:chOff x="0" y="0"/>
+          <a:chExt cx="0" cy="0"/>
+        </a:xfrm>
+      </p:grpSpPr>
+      <p:sp>
+        <p:nvSpPr>
+          <p:cNvPr id="2" name="Title 1">
+            <a:extLst>
+              <a:ext uri="{FF2B5EF4-FFF2-40B4-BE49-F238E27FC236}">
+                <a16:creationId xmlns:a16="http://schemas.microsoft.com/office/drawing/2014/main" id="{FB278B72-CD3E-08E8-F4E6-9CD07C33ED69}"/>
+              </a:ext>
+            </a:extLst>
+          </p:cNvPr>
+          <p:cNvSpPr>
+            <a:spLocks noGrp="1"/>
+          </p:cNvSpPr>
+          <p:nvPr>
+            <p:ph type="title"/>
+          </p:nvPr>
+        </p:nvSpPr>
+        <p:spPr/>
+        <p:txBody>
+          <a:bodyPr/>
+          <a:lstStyle/>
+          <a:p>
+            <a:r>
+              <a:rPr lang="en-US" dirty="0"/>
+              <a:t>Air pollution - </a:t>
+            </a:r>
+            <a:r>
+              <a:rPr lang="de-DE" dirty="0" err="1"/>
+              <a:t>achievements</a:t>
+            </a:r>
+            <a:endParaRPr lang="en-US" sz="3200" dirty="0" err="1"/>
+          </a:p>
+        </p:txBody>
+      </p:sp>
+      <p:sp>
+        <p:nvSpPr>
+          <p:cNvPr id="4" name="Slide Number Placeholder 3">
+            <a:extLst>
+              <a:ext uri="{FF2B5EF4-FFF2-40B4-BE49-F238E27FC236}">
+                <a16:creationId xmlns:a16="http://schemas.microsoft.com/office/drawing/2014/main" id="{01E686C7-06B4-4C6D-DAA3-586F6F99B7B7}"/>
+              </a:ext>
+            </a:extLst>
+          </p:cNvPr>
+          <p:cNvSpPr>
+            <a:spLocks noGrp="1"/>
+          </p:cNvSpPr>
+          <p:nvPr>
+            <p:ph type="sldNum" sz="quarter" idx="4"/>
+          </p:nvPr>
+        </p:nvSpPr>
+        <p:spPr/>
+        <p:txBody>
+          <a:bodyPr/>
+          <a:lstStyle/>
+          <a:p>
+            <a:fld id="{B5CEABB6-07DC-46E8-9B57-56EC44A396E5}" type="slidenum">
+              <a:rPr lang="en-US" smtClean="0"/>
+              <a:pPr/>
+              <a:t>7</a:t>
+            </a:fld>
+            <a:endParaRPr lang="en-US" dirty="0"/>
+          </a:p>
+        </p:txBody>
+      </p:sp>
+      <p:pic>
+        <p:nvPicPr>
+          <p:cNvPr id="8" name="Grafik 7">
+            <a:extLst>
+              <a:ext uri="{FF2B5EF4-FFF2-40B4-BE49-F238E27FC236}">
+                <a16:creationId xmlns:a16="http://schemas.microsoft.com/office/drawing/2014/main" id="{303C9219-C193-EDD6-6377-DA1C34619831}"/>
+              </a:ext>
+            </a:extLst>
+          </p:cNvPr>
+          <p:cNvPicPr>
+            <a:picLocks noChangeAspect="1"/>
+          </p:cNvPicPr>
+          <p:nvPr/>
+        </p:nvPicPr>
+        <p:blipFill>
+          <a:blip r:embed="rId3"/>
+          <a:stretch>
+            <a:fillRect/>
+          </a:stretch>
+        </p:blipFill>
+        <p:spPr>
+          <a:xfrm>
+            <a:off x="8529857" y="709233"/>
+            <a:ext cx="2981741" cy="5439534"/>
+          </a:xfrm>
+          <a:prstGeom prst="rect">
+            <a:avLst/>
+          </a:prstGeom>
+        </p:spPr>
+      </p:pic>
+      <p:pic>
+        <p:nvPicPr>
+          <p:cNvPr id="12" name="Inhaltsplatzhalter 11">
+            <a:extLst>
+              <a:ext uri="{FF2B5EF4-FFF2-40B4-BE49-F238E27FC236}">
+                <a16:creationId xmlns:a16="http://schemas.microsoft.com/office/drawing/2014/main" id="{6216248F-BB62-9076-6D65-8FF114BDE0DD}"/>
+              </a:ext>
+            </a:extLst>
+          </p:cNvPr>
+          <p:cNvPicPr>
+            <a:picLocks noGrp="1" noChangeAspect="1"/>
+          </p:cNvPicPr>
+          <p:nvPr>
+            <p:ph sz="quarter" idx="10"/>
+          </p:nvPr>
+        </p:nvPicPr>
+        <p:blipFill>
+          <a:blip r:embed="rId4"/>
+          <a:stretch>
+            <a:fillRect/>
+          </a:stretch>
+        </p:blipFill>
+        <p:spPr>
+          <a:xfrm>
+            <a:off x="914111" y="2011680"/>
+            <a:ext cx="7273925" cy="1887769"/>
+          </a:xfrm>
+          <a:prstGeom prst="rect">
+            <a:avLst/>
+          </a:prstGeom>
+        </p:spPr>
+      </p:pic>
+    </p:spTree>
+    <p:extLst>
+      <p:ext uri="{BB962C8B-B14F-4D97-AF65-F5344CB8AC3E}">
+        <p14:creationId xmlns:p14="http://schemas.microsoft.com/office/powerpoint/2010/main" val="3073999909"/>
+      </p:ext>
+    </p:extLst>
+  </p:cSld>
+  <p:clrMapOvr>
+    <a:masterClrMapping/>
+  </p:clrMapOvr>
+</p:sld>
+</file>
+
+<file path=ppt/slides/slide8.xml><?xml version="1.0" encoding="utf-8"?>
+<p:sld xmlns:a="http://schemas.openxmlformats.org/drawingml/2006/main" xmlns:r="http://schemas.openxmlformats.org/officeDocument/2006/relationships" xmlns:p="http://schemas.openxmlformats.org/presentationml/2006/main">
+  <p:cSld>
+    <p:spTree>
+      <p:nvGrpSpPr>
+        <p:cNvPr id="1" name="">
+          <a:extLst>
+            <a:ext uri="{FF2B5EF4-FFF2-40B4-BE49-F238E27FC236}">
+              <a16:creationId xmlns:a16="http://schemas.microsoft.com/office/drawing/2014/main" id="{64EA0731-FAA8-93CA-20F3-A8FD0574983C}"/>
+            </a:ext>
+          </a:extLst>
+        </p:cNvPr>
+        <p:cNvGrpSpPr/>
+        <p:nvPr/>
+      </p:nvGrpSpPr>
+      <p:grpSpPr>
+        <a:xfrm>
+          <a:off x="0" y="0"/>
+          <a:ext cx="0" cy="0"/>
+          <a:chOff x="0" y="0"/>
+          <a:chExt cx="0" cy="0"/>
+        </a:xfrm>
+      </p:grpSpPr>
+      <p:sp>
+        <p:nvSpPr>
+          <p:cNvPr id="2" name="Title 1">
+            <a:extLst>
+              <a:ext uri="{FF2B5EF4-FFF2-40B4-BE49-F238E27FC236}">
+                <a16:creationId xmlns:a16="http://schemas.microsoft.com/office/drawing/2014/main" id="{BF4C39F1-C4AE-D04A-D199-9DBFB39CCC52}"/>
+              </a:ext>
+            </a:extLst>
+          </p:cNvPr>
+          <p:cNvSpPr>
+            <a:spLocks noGrp="1"/>
+          </p:cNvSpPr>
+          <p:nvPr>
+            <p:ph type="title"/>
+          </p:nvPr>
+        </p:nvSpPr>
+        <p:spPr>
+          <a:xfrm>
+            <a:off x="914399" y="365125"/>
+            <a:ext cx="9390581" cy="1646555"/>
+          </a:xfrm>
+        </p:spPr>
+        <p:txBody>
+          <a:bodyPr/>
+          <a:lstStyle/>
+          <a:p>
+            <a:r>
+              <a:rPr lang="en-US" dirty="0"/>
+              <a:t>Air pollution – Monthly Average Germany</a:t>
+            </a:r>
+            <a:endParaRPr lang="en-US" sz="3200" dirty="0"/>
+          </a:p>
+        </p:txBody>
+      </p:sp>
+      <p:sp>
+        <p:nvSpPr>
+          <p:cNvPr id="4" name="Slide Number Placeholder 3">
+            <a:extLst>
+              <a:ext uri="{FF2B5EF4-FFF2-40B4-BE49-F238E27FC236}">
+                <a16:creationId xmlns:a16="http://schemas.microsoft.com/office/drawing/2014/main" id="{80A60E58-CB83-56F7-F6FF-2A0BB932813A}"/>
+              </a:ext>
+            </a:extLst>
+          </p:cNvPr>
+          <p:cNvSpPr>
+            <a:spLocks noGrp="1"/>
+          </p:cNvSpPr>
+          <p:nvPr>
+            <p:ph type="sldNum" sz="quarter" idx="4"/>
+          </p:nvPr>
+        </p:nvSpPr>
+        <p:spPr/>
+        <p:txBody>
+          <a:bodyPr/>
+          <a:lstStyle/>
+          <a:p>
+            <a:fld id="{B5CEABB6-07DC-46E8-9B57-56EC44A396E5}" type="slidenum">
+              <a:rPr lang="en-US" smtClean="0"/>
+              <a:pPr/>
+              <a:t>8</a:t>
+            </a:fld>
+            <a:endParaRPr lang="en-US" dirty="0"/>
+          </a:p>
+        </p:txBody>
+      </p:sp>
+      <p:pic>
+        <p:nvPicPr>
+          <p:cNvPr id="5" name="Inhaltsplatzhalter 4">
+            <a:extLst>
+              <a:ext uri="{FF2B5EF4-FFF2-40B4-BE49-F238E27FC236}">
+                <a16:creationId xmlns:a16="http://schemas.microsoft.com/office/drawing/2014/main" id="{692E27E8-A333-15F7-7B9D-45FDA18C2D44}"/>
+              </a:ext>
+            </a:extLst>
+          </p:cNvPr>
+          <p:cNvPicPr>
+            <a:picLocks noGrp="1" noChangeAspect="1"/>
+          </p:cNvPicPr>
+          <p:nvPr>
+            <p:ph sz="quarter" idx="10"/>
+          </p:nvPr>
+        </p:nvPicPr>
+        <p:blipFill>
+          <a:blip r:embed="rId3"/>
+          <a:stretch>
+            <a:fillRect/>
+          </a:stretch>
+        </p:blipFill>
+        <p:spPr>
+          <a:xfrm>
+            <a:off x="914400" y="2214633"/>
+            <a:ext cx="7273925" cy="3749535"/>
+          </a:xfrm>
+          <a:prstGeom prst="rect">
+            <a:avLst/>
+          </a:prstGeom>
+        </p:spPr>
+      </p:pic>
+    </p:spTree>
+    <p:extLst>
+      <p:ext uri="{BB962C8B-B14F-4D97-AF65-F5344CB8AC3E}">
+        <p14:creationId xmlns:p14="http://schemas.microsoft.com/office/powerpoint/2010/main" val="294331212"/>
+      </p:ext>
+    </p:extLst>
+  </p:cSld>
+  <p:clrMapOvr>
+    <a:masterClrMapping/>
+  </p:clrMapOvr>
+</p:sld>
+</file>
+
+<file path=ppt/slides/slide9.xml><?xml version="1.0" encoding="utf-8"?>
 <p:sld xmlns:a="http://schemas.openxmlformats.org/drawingml/2006/main" xmlns:r="http://schemas.openxmlformats.org/officeDocument/2006/relationships" xmlns:p="http://schemas.openxmlformats.org/presentationml/2006/main">
   <p:cSld>
     <p:spTree>
@@ -7876,7 +9219,7 @@
         <p:spPr>
           <a:xfrm>
             <a:off x="914399" y="365125"/>
-            <a:ext cx="8458201" cy="1646555"/>
+            <a:ext cx="9719354" cy="1646555"/>
           </a:xfrm>
         </p:spPr>
         <p:txBody>
@@ -7923,7 +9266,7 @@
             <a:fld id="{B5CEABB6-07DC-46E8-9B57-56EC44A396E5}" type="slidenum">
               <a:rPr lang="en-US" smtClean="0"/>
               <a:pPr/>
-              <a:t>7</a:t>
+              <a:t>9</a:t>
             </a:fld>
             <a:endParaRPr lang="en-US" dirty="0"/>
           </a:p>
@@ -8040,282 +9383,6 @@
     <p:extLst>
       <p:ext uri="{BB962C8B-B14F-4D97-AF65-F5344CB8AC3E}">
         <p14:creationId xmlns:p14="http://schemas.microsoft.com/office/powerpoint/2010/main" val="2338652797"/>
-      </p:ext>
-    </p:extLst>
-  </p:cSld>
-  <p:clrMapOvr>
-    <a:masterClrMapping/>
-  </p:clrMapOvr>
-</p:sld>
-</file>
-
-<file path=ppt/slides/slide8.xml><?xml version="1.0" encoding="utf-8"?>
-<p:sld xmlns:a="http://schemas.openxmlformats.org/drawingml/2006/main" xmlns:r="http://schemas.openxmlformats.org/officeDocument/2006/relationships" xmlns:p="http://schemas.openxmlformats.org/presentationml/2006/main">
-  <p:cSld>
-    <p:spTree>
-      <p:nvGrpSpPr>
-        <p:cNvPr id="1" name="">
-          <a:extLst>
-            <a:ext uri="{FF2B5EF4-FFF2-40B4-BE49-F238E27FC236}">
-              <a16:creationId xmlns:a16="http://schemas.microsoft.com/office/drawing/2014/main" id="{6E0ED1D8-39DE-BEEA-2E92-EADD1C617D2E}"/>
-            </a:ext>
-          </a:extLst>
-        </p:cNvPr>
-        <p:cNvGrpSpPr/>
-        <p:nvPr/>
-      </p:nvGrpSpPr>
-      <p:grpSpPr>
-        <a:xfrm>
-          <a:off x="0" y="0"/>
-          <a:ext cx="0" cy="0"/>
-          <a:chOff x="0" y="0"/>
-          <a:chExt cx="0" cy="0"/>
-        </a:xfrm>
-      </p:grpSpPr>
-      <p:sp>
-        <p:nvSpPr>
-          <p:cNvPr id="2" name="Title 1">
-            <a:extLst>
-              <a:ext uri="{FF2B5EF4-FFF2-40B4-BE49-F238E27FC236}">
-                <a16:creationId xmlns:a16="http://schemas.microsoft.com/office/drawing/2014/main" id="{E9F4B7ED-378C-E150-755A-961AF8262B21}"/>
-              </a:ext>
-            </a:extLst>
-          </p:cNvPr>
-          <p:cNvSpPr>
-            <a:spLocks noGrp="1"/>
-          </p:cNvSpPr>
-          <p:nvPr>
-            <p:ph type="title"/>
-          </p:nvPr>
-        </p:nvSpPr>
-        <p:spPr>
-          <a:xfrm>
-            <a:off x="914399" y="365125"/>
-            <a:ext cx="8458201" cy="1646555"/>
-          </a:xfrm>
-        </p:spPr>
-        <p:txBody>
-          <a:bodyPr/>
-          <a:lstStyle/>
-          <a:p>
-            <a:r>
-              <a:rPr lang="en-US" dirty="0"/>
-              <a:t>Air Pollution</a:t>
-            </a:r>
-            <a:r>
-              <a:rPr lang="en-US" sz="3200" dirty="0"/>
-              <a:t> – Api Outpu</a:t>
-            </a:r>
-            <a:r>
-              <a:rPr lang="en-US" dirty="0"/>
-              <a:t>t X</a:t>
-            </a:r>
-            <a:endParaRPr lang="en-US" sz="3200" dirty="0"/>
-          </a:p>
-        </p:txBody>
-      </p:sp>
-      <p:sp>
-        <p:nvSpPr>
-          <p:cNvPr id="4" name="Slide Number Placeholder 3">
-            <a:extLst>
-              <a:ext uri="{FF2B5EF4-FFF2-40B4-BE49-F238E27FC236}">
-                <a16:creationId xmlns:a16="http://schemas.microsoft.com/office/drawing/2014/main" id="{13A991BC-D2F0-CC6E-6E3D-FADC54FDA1BD}"/>
-              </a:ext>
-            </a:extLst>
-          </p:cNvPr>
-          <p:cNvSpPr>
-            <a:spLocks noGrp="1"/>
-          </p:cNvSpPr>
-          <p:nvPr>
-            <p:ph type="sldNum" sz="quarter" idx="4"/>
-          </p:nvPr>
-        </p:nvSpPr>
-        <p:spPr/>
-        <p:txBody>
-          <a:bodyPr/>
-          <a:lstStyle/>
-          <a:p>
-            <a:fld id="{B5CEABB6-07DC-46E8-9B57-56EC44A396E5}" type="slidenum">
-              <a:rPr lang="en-US" smtClean="0"/>
-              <a:pPr/>
-              <a:t>8</a:t>
-            </a:fld>
-            <a:endParaRPr lang="en-US" dirty="0"/>
-          </a:p>
-        </p:txBody>
-      </p:sp>
-      <p:sp>
-        <p:nvSpPr>
-          <p:cNvPr id="6" name="Content Placeholder 5">
-            <a:extLst>
-              <a:ext uri="{FF2B5EF4-FFF2-40B4-BE49-F238E27FC236}">
-                <a16:creationId xmlns:a16="http://schemas.microsoft.com/office/drawing/2014/main" id="{083D3823-C3EB-FC1E-1018-EACEC1CBAA34}"/>
-              </a:ext>
-            </a:extLst>
-          </p:cNvPr>
-          <p:cNvSpPr>
-            <a:spLocks noGrp="1"/>
-          </p:cNvSpPr>
-          <p:nvPr>
-            <p:ph sz="quarter" idx="10"/>
-          </p:nvPr>
-        </p:nvSpPr>
-        <p:spPr/>
-        <p:txBody>
-          <a:bodyPr>
-            <a:normAutofit/>
-          </a:bodyPr>
-          <a:lstStyle/>
-          <a:p>
-            <a:pPr marL="0" lvl="0" indent="0">
-              <a:buNone/>
-            </a:pPr>
-            <a:endParaRPr lang="en-DE" sz="1600" dirty="0"/>
-          </a:p>
-        </p:txBody>
-      </p:sp>
-    </p:spTree>
-    <p:extLst>
-      <p:ext uri="{BB962C8B-B14F-4D97-AF65-F5344CB8AC3E}">
-        <p14:creationId xmlns:p14="http://schemas.microsoft.com/office/powerpoint/2010/main" val="1185632820"/>
-      </p:ext>
-    </p:extLst>
-  </p:cSld>
-  <p:clrMapOvr>
-    <a:masterClrMapping/>
-  </p:clrMapOvr>
-</p:sld>
-</file>
-
-<file path=ppt/slides/slide9.xml><?xml version="1.0" encoding="utf-8"?>
-<p:sld xmlns:a="http://schemas.openxmlformats.org/drawingml/2006/main" xmlns:r="http://schemas.openxmlformats.org/officeDocument/2006/relationships" xmlns:p="http://schemas.openxmlformats.org/presentationml/2006/main">
-  <p:cSld>
-    <p:spTree>
-      <p:nvGrpSpPr>
-        <p:cNvPr id="1" name="">
-          <a:extLst>
-            <a:ext uri="{FF2B5EF4-FFF2-40B4-BE49-F238E27FC236}">
-              <a16:creationId xmlns:a16="http://schemas.microsoft.com/office/drawing/2014/main" id="{B17F2D26-E0CC-D3F8-2F90-2DD9D260CBB4}"/>
-            </a:ext>
-          </a:extLst>
-        </p:cNvPr>
-        <p:cNvGrpSpPr/>
-        <p:nvPr/>
-      </p:nvGrpSpPr>
-      <p:grpSpPr>
-        <a:xfrm>
-          <a:off x="0" y="0"/>
-          <a:ext cx="0" cy="0"/>
-          <a:chOff x="0" y="0"/>
-          <a:chExt cx="0" cy="0"/>
-        </a:xfrm>
-      </p:grpSpPr>
-      <p:sp>
-        <p:nvSpPr>
-          <p:cNvPr id="2" name="Title 1">
-            <a:extLst>
-              <a:ext uri="{FF2B5EF4-FFF2-40B4-BE49-F238E27FC236}">
-                <a16:creationId xmlns:a16="http://schemas.microsoft.com/office/drawing/2014/main" id="{F14F2DDA-6ABA-4FCD-2F59-91B0253CA16B}"/>
-              </a:ext>
-            </a:extLst>
-          </p:cNvPr>
-          <p:cNvSpPr>
-            <a:spLocks noGrp="1"/>
-          </p:cNvSpPr>
-          <p:nvPr>
-            <p:ph type="title"/>
-          </p:nvPr>
-        </p:nvSpPr>
-        <p:spPr>
-          <a:xfrm>
-            <a:off x="914399" y="365125"/>
-            <a:ext cx="8458201" cy="1646555"/>
-          </a:xfrm>
-        </p:spPr>
-        <p:txBody>
-          <a:bodyPr/>
-          <a:lstStyle/>
-          <a:p>
-            <a:r>
-              <a:rPr lang="en-US" dirty="0"/>
-              <a:t>Air Pollution</a:t>
-            </a:r>
-            <a:r>
-              <a:rPr lang="en-US" sz="3200" dirty="0"/>
-              <a:t> – Api Outpu</a:t>
-            </a:r>
-            <a:r>
-              <a:rPr lang="en-US" dirty="0"/>
-              <a:t>t X</a:t>
-            </a:r>
-            <a:endParaRPr lang="en-US" sz="3200" dirty="0"/>
-          </a:p>
-        </p:txBody>
-      </p:sp>
-      <p:sp>
-        <p:nvSpPr>
-          <p:cNvPr id="4" name="Slide Number Placeholder 3">
-            <a:extLst>
-              <a:ext uri="{FF2B5EF4-FFF2-40B4-BE49-F238E27FC236}">
-                <a16:creationId xmlns:a16="http://schemas.microsoft.com/office/drawing/2014/main" id="{D13B2B89-1D29-99F9-1482-6A9FA7915706}"/>
-              </a:ext>
-            </a:extLst>
-          </p:cNvPr>
-          <p:cNvSpPr>
-            <a:spLocks noGrp="1"/>
-          </p:cNvSpPr>
-          <p:nvPr>
-            <p:ph type="sldNum" sz="quarter" idx="4"/>
-          </p:nvPr>
-        </p:nvSpPr>
-        <p:spPr/>
-        <p:txBody>
-          <a:bodyPr/>
-          <a:lstStyle/>
-          <a:p>
-            <a:fld id="{B5CEABB6-07DC-46E8-9B57-56EC44A396E5}" type="slidenum">
-              <a:rPr lang="en-US" smtClean="0"/>
-              <a:pPr/>
-              <a:t>9</a:t>
-            </a:fld>
-            <a:endParaRPr lang="en-US" dirty="0"/>
-          </a:p>
-        </p:txBody>
-      </p:sp>
-      <p:sp>
-        <p:nvSpPr>
-          <p:cNvPr id="6" name="Content Placeholder 5">
-            <a:extLst>
-              <a:ext uri="{FF2B5EF4-FFF2-40B4-BE49-F238E27FC236}">
-                <a16:creationId xmlns:a16="http://schemas.microsoft.com/office/drawing/2014/main" id="{A3698340-C24A-E811-4C27-2815D6736E7B}"/>
-              </a:ext>
-            </a:extLst>
-          </p:cNvPr>
-          <p:cNvSpPr>
-            <a:spLocks noGrp="1"/>
-          </p:cNvSpPr>
-          <p:nvPr>
-            <p:ph sz="quarter" idx="10"/>
-          </p:nvPr>
-        </p:nvSpPr>
-        <p:spPr/>
-        <p:txBody>
-          <a:bodyPr>
-            <a:normAutofit/>
-          </a:bodyPr>
-          <a:lstStyle/>
-          <a:p>
-            <a:pPr marL="0" lvl="0" indent="0">
-              <a:buNone/>
-            </a:pPr>
-            <a:endParaRPr lang="en-DE" sz="1600" dirty="0"/>
-          </a:p>
-        </p:txBody>
-      </p:sp>
-    </p:spTree>
-    <p:extLst>
-      <p:ext uri="{BB962C8B-B14F-4D97-AF65-F5344CB8AC3E}">
-        <p14:creationId xmlns:p14="http://schemas.microsoft.com/office/powerpoint/2010/main" val="2307799448"/>
       </p:ext>
     </p:extLst>
   </p:cSld>
@@ -9117,6 +10184,15 @@
 </file>
 
 <file path=customXml/item1.xml><?xml version="1.0" encoding="utf-8"?>
+<?mso-contentType ?>
+<FormTemplates xmlns="http://schemas.microsoft.com/sharepoint/v3/contenttype/forms">
+  <Display>DocumentLibraryForm</Display>
+  <Edit>DocumentLibraryForm</Edit>
+  <New>DocumentLibraryForm</New>
+</FormTemplates>
+</file>
+
+<file path=customXml/item2.xml><?xml version="1.0" encoding="utf-8"?>
 <ct:contentTypeSchema xmlns:ct="http://schemas.microsoft.com/office/2006/metadata/contentType" xmlns:ma="http://schemas.microsoft.com/office/2006/metadata/properties/metaAttributes" ct:_="" ma:_="" ma:contentTypeName="Document" ma:contentTypeID="0x01010079F111ED35F8CC479449609E8A0923A6" ma:contentTypeVersion="28" ma:contentTypeDescription="Create a new document." ma:contentTypeScope="" ma:versionID="60f5a4f2d2b0abadcf532d48ebf9cb71">
   <xsd:schema xmlns:xsd="http://www.w3.org/2001/XMLSchema" xmlns:xs="http://www.w3.org/2001/XMLSchema" xmlns:p="http://schemas.microsoft.com/office/2006/metadata/properties" xmlns:ns1="http://schemas.microsoft.com/sharepoint/v3" xmlns:ns2="71af3243-3dd4-4a8d-8c0d-dd76da1f02a5" xmlns:ns3="16c05727-aa75-4e4a-9b5f-8a80a1165891" xmlns:ns4="230e9df3-be65-4c73-a93b-d1236ebd677e" targetNamespace="http://schemas.microsoft.com/office/2006/metadata/properties" ma:root="true" ma:fieldsID="7dd78129e6a1811f84807ad11c651531" ns1:_="" ns2:_="" ns3:_="" ns4:_="">
     <xsd:import namespace="http://schemas.microsoft.com/sharepoint/v3"/>
@@ -9428,7 +10504,7 @@
 </ct:contentTypeSchema>
 </file>
 
-<file path=customXml/item2.xml><?xml version="1.0" encoding="utf-8"?>
+<file path=customXml/item3.xml><?xml version="1.0" encoding="utf-8"?>
 <p:properties xmlns:p="http://schemas.microsoft.com/office/2006/metadata/properties" xmlns:xsi="http://www.w3.org/2001/XMLSchema-instance" xmlns:pc="http://schemas.microsoft.com/office/infopath/2007/PartnerControls">
   <documentManagement>
     <_ip_UnifiedCompliancePolicyUIAction xmlns="http://schemas.microsoft.com/sharepoint/v3" xsi:nil="true"/>
@@ -9448,16 +10524,15 @@
 </p:properties>
 </file>
 
-<file path=customXml/item3.xml><?xml version="1.0" encoding="utf-8"?>
-<?mso-contentType ?>
-<FormTemplates xmlns="http://schemas.microsoft.com/sharepoint/v3/contenttype/forms">
-  <Display>DocumentLibraryForm</Display>
-  <Edit>DocumentLibraryForm</Edit>
-  <New>DocumentLibraryForm</New>
-</FormTemplates>
+<file path=customXml/itemProps1.xml><?xml version="1.0" encoding="utf-8"?>
+<ds:datastoreItem xmlns:ds="http://schemas.openxmlformats.org/officeDocument/2006/customXml" ds:itemID="{B7B39BD0-040C-43BE-B0E4-512B09E8003F}">
+  <ds:schemaRefs>
+    <ds:schemaRef ds:uri="http://schemas.microsoft.com/sharepoint/v3/contenttype/forms"/>
+  </ds:schemaRefs>
+</ds:datastoreItem>
 </file>
 
-<file path=customXml/itemProps1.xml><?xml version="1.0" encoding="utf-8"?>
+<file path=customXml/itemProps2.xml><?xml version="1.0" encoding="utf-8"?>
 <ds:datastoreItem xmlns:ds="http://schemas.openxmlformats.org/officeDocument/2006/customXml" ds:itemID="{622457D9-12AC-4794-A05E-F1B90FCD8DA7}">
   <ds:schemaRefs>
     <ds:schemaRef ds:uri="http://schemas.microsoft.com/office/2006/metadata/contentType"/>
@@ -9478,7 +10553,7 @@
 </ds:datastoreItem>
 </file>
 
-<file path=customXml/itemProps2.xml><?xml version="1.0" encoding="utf-8"?>
+<file path=customXml/itemProps3.xml><?xml version="1.0" encoding="utf-8"?>
 <ds:datastoreItem xmlns:ds="http://schemas.openxmlformats.org/officeDocument/2006/customXml" ds:itemID="{AB045227-5724-4DBF-9712-031B1BFB2C3C}">
   <ds:schemaRefs>
     <ds:schemaRef ds:uri="http://schemas.microsoft.com/office/2006/metadata/properties"/>
@@ -9490,14 +10565,6 @@
 </ds:datastoreItem>
 </file>
 
-<file path=customXml/itemProps3.xml><?xml version="1.0" encoding="utf-8"?>
-<ds:datastoreItem xmlns:ds="http://schemas.openxmlformats.org/officeDocument/2006/customXml" ds:itemID="{B7B39BD0-040C-43BE-B0E4-512B09E8003F}">
-  <ds:schemaRefs>
-    <ds:schemaRef ds:uri="http://schemas.microsoft.com/sharepoint/v3/contenttype/forms"/>
-  </ds:schemaRefs>
-</ds:datastoreItem>
-</file>
-
 <file path=docMetadata/LabelInfo.xml><?xml version="1.0" encoding="utf-8"?>
 <clbl:labelList xmlns:clbl="http://schemas.microsoft.com/office/2020/mipLabelMetadata"/>
 </file>
</xml_diff>